<commit_message>
Add bridge slide linking sustainability dimensions to original lecture sections
Co-Authored-By: Claude Opus 5.5 <noreply@anthropic.com>
Claude-Session: https://claude.ai/code/session_015QQoGwFQ5zRfCX9EMYaD2s
</commit_message>
<xml_diff>
--- a/lectures/التصميم_المستدام_الجزء_الثاني_موسع.pptx
+++ b/lectures/التصميم_المستدام_الجزء_الثاني_موسع.pptx
@@ -19,6 +19,7 @@
     <p:sldId id="293" r:id="rId20"/>
     <p:sldId id="294" r:id="rId21"/>
     <p:sldId id="295" r:id="rId22"/>
+    <p:sldId id="296" r:id="rId23"/>
     <p:sldId id="283" r:id="rId4"/>
     <p:sldId id="284" r:id="rId5"/>
     <p:sldId id="285" r:id="rId6"/>
@@ -26,8 +27,8 @@
     <p:sldId id="287" r:id="rId8"/>
     <p:sldId id="288" r:id="rId9"/>
     <p:sldId id="289" r:id="rId10"/>
-    <p:sldId id="296" r:id="rId23"/>
     <p:sldId id="297" r:id="rId24"/>
+    <p:sldId id="298" r:id="rId25"/>
   </p:sldIdLst>
   <p:sldSz cx="12192000" cy="6858000"/>
   <p:notesSz cx="6858000" cy="9144000"/>
@@ -5026,7 +5027,7 @@
             </a:pPr>
             <a:r>
               <a:rPr lang="ar-SA" sz="2000" dirty="0"/>
-              <a:t xml:space="preserve">عرّفت اللجنة العالمية للبيئة والتنمية (تقرير برونتلاند، 1987) التنمية المستدامة بأنها: </a:t>
+              <a:t xml:space="preserve">قبل أن نصمم عبوة مستدامة، علينا أن نفهم معنى الاستدامة نفسها؛ فقد عرّفت اللجنة العالمية للبيئة والتنمية (تقرير برونتلاند، 1987) التنمية المستدامة بأنها: </a:t>
             </a:r>
             <a:r>
               <a:rPr lang="ar-SA" sz="2000" b="1" dirty="0"/>
@@ -7312,6 +7313,417 @@
         <p:cNvPr id="1" name="">
           <a:extLst>
             <a:ext uri="{FF2B5EF4-FFF2-40B4-BE49-F238E27FC236}">
+              <a16:creationId xmlns:a16="http://schemas.microsoft.com/office/drawing/2014/main" id="{DC9E0AF2-3BCD-A585-3237-E7D711FAE6AC}"/>
+            </a:ext>
+          </a:extLst>
+        </p:cNvPr>
+        <p:cNvGrpSpPr/>
+        <p:nvPr/>
+      </p:nvGrpSpPr>
+      <p:grpSpPr>
+        <a:xfrm>
+          <a:off x="0" y="0"/>
+          <a:ext cx="0" cy="0"/>
+          <a:chOff x="0" y="0"/>
+          <a:chExt cx="0" cy="0"/>
+        </a:xfrm>
+      </p:grpSpPr>
+      <p:sp>
+        <p:nvSpPr>
+          <p:cNvPr id="15" name="Footer Placeholder 3">
+            <a:extLst>
+              <a:ext uri="{FF2B5EF4-FFF2-40B4-BE49-F238E27FC236}">
+                <a16:creationId xmlns:a16="http://schemas.microsoft.com/office/drawing/2014/main" id="{CB9AC83B-DA0D-C284-A37F-CC85BC432DA7}"/>
+              </a:ext>
+            </a:extLst>
+          </p:cNvPr>
+          <p:cNvSpPr>
+            <a:spLocks noGrp="1"/>
+          </p:cNvSpPr>
+          <p:nvPr>
+            <p:ph type="ftr" sz="quarter" idx="11"/>
+          </p:nvPr>
+        </p:nvSpPr>
+        <p:spPr>
+          <a:xfrm>
+            <a:off x="4038600" y="6356350"/>
+            <a:ext cx="4114800" cy="365125"/>
+          </a:xfrm>
+        </p:spPr>
+        <p:txBody>
+          <a:bodyPr/>
+          <a:lstStyle/>
+          <a:p>
+            <a:r>
+              <a:rPr lang="ar-SA" dirty="0"/>
+              <a:t>برنامج التصميم الجرافيكي - المستوى السادس</a:t>
+            </a:r>
+            <a:endParaRPr lang="en-US" dirty="0"/>
+          </a:p>
+        </p:txBody>
+      </p:sp>
+      <p:sp>
+        <p:nvSpPr>
+          <p:cNvPr id="3" name="Content Placeholder 2">
+            <a:extLst>
+              <a:ext uri="{FF2B5EF4-FFF2-40B4-BE49-F238E27FC236}">
+                <a16:creationId xmlns:a16="http://schemas.microsoft.com/office/drawing/2014/main" id="{A460509A-394E-062D-DA54-BD283A37F314}"/>
+              </a:ext>
+            </a:extLst>
+          </p:cNvPr>
+          <p:cNvSpPr txBox="1">
+            <a:spLocks/>
+          </p:cNvSpPr>
+          <p:nvPr/>
+        </p:nvSpPr>
+        <p:spPr>
+          <a:xfrm>
+            <a:off x="4402666" y="1416963"/>
+            <a:ext cx="6920176" cy="1030380"/>
+          </a:xfrm>
+          <a:prstGeom prst="rect">
+            <a:avLst/>
+          </a:prstGeom>
+        </p:spPr>
+        <p:txBody>
+          <a:bodyPr vert="horz" lIns="91440" tIns="45720" rIns="91440" bIns="45720" rtlCol="0">
+            <a:noAutofit/>
+          </a:bodyPr>
+          <a:lstStyle>
+            <a:lvl1pPr marL="228600" indent="-228600" algn="r" defTabSz="914400" rtl="1" eaLnBrk="1" latinLnBrk="0" hangingPunct="1">
+              <a:lnSpc>
+                <a:spcPct val="90000"/>
+              </a:lnSpc>
+              <a:spcBef>
+                <a:spcPts val="1000"/>
+              </a:spcBef>
+              <a:buFont typeface="Arial" panose="020B0604020202020204" pitchFamily="34" charset="0"/>
+              <a:buChar char="•"/>
+              <a:defRPr sz="2800" kern="1200">
+                <a:solidFill>
+                  <a:schemeClr val="tx1"/>
+                </a:solidFill>
+                <a:latin typeface="Sakkal Majalla" panose="02000000000000000000" pitchFamily="2" charset="-78"/>
+                <a:ea typeface="+mn-ea"/>
+                <a:cs typeface="Sakkal Majalla" panose="02000000000000000000" pitchFamily="2" charset="-78"/>
+              </a:defRPr>
+            </a:lvl1pPr>
+            <a:lvl2pPr marL="685800" indent="-228600" algn="r" defTabSz="914400" rtl="1" eaLnBrk="1" latinLnBrk="0" hangingPunct="1">
+              <a:lnSpc>
+                <a:spcPct val="90000"/>
+              </a:lnSpc>
+              <a:spcBef>
+                <a:spcPts val="500"/>
+              </a:spcBef>
+              <a:buFont typeface="Arial" panose="020B0604020202020204" pitchFamily="34" charset="0"/>
+              <a:buChar char="•"/>
+              <a:defRPr sz="2400" kern="1200">
+                <a:solidFill>
+                  <a:schemeClr val="tx1"/>
+                </a:solidFill>
+                <a:latin typeface="Sakkal Majalla" panose="02000000000000000000" pitchFamily="2" charset="-78"/>
+                <a:ea typeface="+mn-ea"/>
+                <a:cs typeface="Sakkal Majalla" panose="02000000000000000000" pitchFamily="2" charset="-78"/>
+              </a:defRPr>
+            </a:lvl2pPr>
+            <a:lvl3pPr marL="1143000" indent="-228600" algn="r" defTabSz="914400" rtl="1" eaLnBrk="1" latinLnBrk="0" hangingPunct="1">
+              <a:lnSpc>
+                <a:spcPct val="90000"/>
+              </a:lnSpc>
+              <a:spcBef>
+                <a:spcPts val="500"/>
+              </a:spcBef>
+              <a:buFont typeface="Arial" panose="020B0604020202020204" pitchFamily="34" charset="0"/>
+              <a:buChar char="•"/>
+              <a:defRPr sz="2000" kern="1200">
+                <a:solidFill>
+                  <a:schemeClr val="tx1"/>
+                </a:solidFill>
+                <a:latin typeface="Sakkal Majalla" panose="02000000000000000000" pitchFamily="2" charset="-78"/>
+                <a:ea typeface="+mn-ea"/>
+                <a:cs typeface="Sakkal Majalla" panose="02000000000000000000" pitchFamily="2" charset="-78"/>
+              </a:defRPr>
+            </a:lvl3pPr>
+            <a:lvl4pPr marL="1600200" indent="-228600" algn="r" defTabSz="914400" rtl="1" eaLnBrk="1" latinLnBrk="0" hangingPunct="1">
+              <a:lnSpc>
+                <a:spcPct val="90000"/>
+              </a:lnSpc>
+              <a:spcBef>
+                <a:spcPts val="500"/>
+              </a:spcBef>
+              <a:buFont typeface="Arial" panose="020B0604020202020204" pitchFamily="34" charset="0"/>
+              <a:buChar char="•"/>
+              <a:defRPr sz="1800" kern="1200">
+                <a:solidFill>
+                  <a:schemeClr val="tx1"/>
+                </a:solidFill>
+                <a:latin typeface="Sakkal Majalla" panose="02000000000000000000" pitchFamily="2" charset="-78"/>
+                <a:ea typeface="+mn-ea"/>
+                <a:cs typeface="Sakkal Majalla" panose="02000000000000000000" pitchFamily="2" charset="-78"/>
+              </a:defRPr>
+            </a:lvl4pPr>
+            <a:lvl5pPr marL="2057400" indent="-228600" algn="r" defTabSz="914400" rtl="1" eaLnBrk="1" latinLnBrk="0" hangingPunct="1">
+              <a:lnSpc>
+                <a:spcPct val="90000"/>
+              </a:lnSpc>
+              <a:spcBef>
+                <a:spcPts val="500"/>
+              </a:spcBef>
+              <a:buFont typeface="Arial" panose="020B0604020202020204" pitchFamily="34" charset="0"/>
+              <a:buChar char="•"/>
+              <a:defRPr sz="1800" kern="1200">
+                <a:solidFill>
+                  <a:schemeClr val="tx1"/>
+                </a:solidFill>
+                <a:latin typeface="Sakkal Majalla" panose="02000000000000000000" pitchFamily="2" charset="-78"/>
+                <a:ea typeface="+mn-ea"/>
+                <a:cs typeface="Sakkal Majalla" panose="02000000000000000000" pitchFamily="2" charset="-78"/>
+              </a:defRPr>
+            </a:lvl5pPr>
+            <a:lvl6pPr marL="2514600" indent="-228600" algn="l" defTabSz="914400" rtl="0" eaLnBrk="1" latinLnBrk="0" hangingPunct="1">
+              <a:lnSpc>
+                <a:spcPct val="90000"/>
+              </a:lnSpc>
+              <a:spcBef>
+                <a:spcPts val="500"/>
+              </a:spcBef>
+              <a:buFont typeface="Arial" panose="020B0604020202020204" pitchFamily="34" charset="0"/>
+              <a:buChar char="•"/>
+              <a:defRPr sz="1800" kern="1200">
+                <a:solidFill>
+                  <a:schemeClr val="tx1"/>
+                </a:solidFill>
+                <a:latin typeface="+mn-lt"/>
+                <a:ea typeface="+mn-ea"/>
+                <a:cs typeface="+mn-cs"/>
+              </a:defRPr>
+            </a:lvl6pPr>
+            <a:lvl7pPr marL="2971800" indent="-228600" algn="l" defTabSz="914400" rtl="0" eaLnBrk="1" latinLnBrk="0" hangingPunct="1">
+              <a:lnSpc>
+                <a:spcPct val="90000"/>
+              </a:lnSpc>
+              <a:spcBef>
+                <a:spcPts val="500"/>
+              </a:spcBef>
+              <a:buFont typeface="Arial" panose="020B0604020202020204" pitchFamily="34" charset="0"/>
+              <a:buChar char="•"/>
+              <a:defRPr sz="1800" kern="1200">
+                <a:solidFill>
+                  <a:schemeClr val="tx1"/>
+                </a:solidFill>
+                <a:latin typeface="+mn-lt"/>
+                <a:ea typeface="+mn-ea"/>
+                <a:cs typeface="+mn-cs"/>
+              </a:defRPr>
+            </a:lvl7pPr>
+            <a:lvl8pPr marL="3429000" indent="-228600" algn="l" defTabSz="914400" rtl="0" eaLnBrk="1" latinLnBrk="0" hangingPunct="1">
+              <a:lnSpc>
+                <a:spcPct val="90000"/>
+              </a:lnSpc>
+              <a:spcBef>
+                <a:spcPts val="500"/>
+              </a:spcBef>
+              <a:buFont typeface="Arial" panose="020B0604020202020204" pitchFamily="34" charset="0"/>
+              <a:buChar char="•"/>
+              <a:defRPr sz="1800" kern="1200">
+                <a:solidFill>
+                  <a:schemeClr val="tx1"/>
+                </a:solidFill>
+                <a:latin typeface="+mn-lt"/>
+                <a:ea typeface="+mn-ea"/>
+                <a:cs typeface="+mn-cs"/>
+              </a:defRPr>
+            </a:lvl8pPr>
+            <a:lvl9pPr marL="3886200" indent="-228600" algn="l" defTabSz="914400" rtl="0" eaLnBrk="1" latinLnBrk="0" hangingPunct="1">
+              <a:lnSpc>
+                <a:spcPct val="90000"/>
+              </a:lnSpc>
+              <a:spcBef>
+                <a:spcPts val="500"/>
+              </a:spcBef>
+              <a:buFont typeface="Arial" panose="020B0604020202020204" pitchFamily="34" charset="0"/>
+              <a:buChar char="•"/>
+              <a:defRPr sz="1800" kern="1200">
+                <a:solidFill>
+                  <a:schemeClr val="tx1"/>
+                </a:solidFill>
+                <a:latin typeface="+mn-lt"/>
+                <a:ea typeface="+mn-ea"/>
+                <a:cs typeface="+mn-cs"/>
+              </a:defRPr>
+            </a:lvl9pPr>
+          </a:lstStyle>
+          <a:p>
+            <a:pPr marL="0" indent="0">
+              <a:buNone/>
+            </a:pPr>
+            <a:r>
+              <a:rPr lang="ar-SA" sz="2000" b="1" dirty="0"/>
+              <a:t>من الأبعاد إلى التطبيق: خريطة المحاضرة</a:t>
+            </a:r>
+            <a:endParaRPr lang="ar-SA" sz="2000" dirty="0"/>
+          </a:p>
+          <a:p>
+            <a:pPr marL="0" indent="0">
+              <a:buNone/>
+            </a:pPr>
+            <a:r>
+              <a:rPr lang="ar-SA" sz="2000" dirty="0"/>
+              <a:t xml:space="preserve">بعد أن تعرفنا على أبعاد الاستدامة، ننتقل إلى </a:t>
+            </a:r>
+            <a:r>
+              <a:rPr lang="ar-SA" sz="2000" b="1" dirty="0"/>
+              <a:t>أدوات المصمم العملية</a:t>
+            </a:r>
+            <a:r>
+              <a:rPr lang="ar-SA" sz="2000" dirty="0"/>
+              <a:t>؛ فكل محور قادم يطبّق بعداً أو أكثر من هذه الأبعاد:</a:t>
+            </a:r>
+            <a:endParaRPr lang="ar-SA" sz="2000" dirty="0"/>
+          </a:p>
+          <a:p>
+            <a:pPr marL="0" indent="0">
+              <a:buNone/>
+            </a:pPr>
+            <a:r>
+              <a:rPr lang="ar-SA" sz="2000" dirty="0"/>
+              <a:t xml:space="preserve">• </a:t>
+            </a:r>
+            <a:r>
+              <a:rPr lang="ar-SA" sz="2000" b="1" dirty="0"/>
+              <a:t>أولاً: هرم النفايات (3Rs)</a:t>
+            </a:r>
+            <a:r>
+              <a:rPr lang="ar-SA" sz="2000" dirty="0"/>
+              <a:t xml:space="preserve"> ← البعد البيئي والاقتصادي (مواد أقل = تكلفة أقل).</a:t>
+            </a:r>
+            <a:endParaRPr lang="ar-SA" sz="2000" dirty="0"/>
+          </a:p>
+          <a:p>
+            <a:pPr marL="0" indent="0">
+              <a:buNone/>
+            </a:pPr>
+            <a:r>
+              <a:rPr lang="ar-SA" sz="2000" dirty="0"/>
+              <a:t xml:space="preserve">• </a:t>
+            </a:r>
+            <a:r>
+              <a:rPr lang="ar-SA" sz="2000" b="1" dirty="0"/>
+              <a:t>ثانياً: التحليل المادي للبلاستيك والورق</a:t>
+            </a:r>
+            <a:r>
+              <a:rPr lang="ar-SA" sz="2000" dirty="0"/>
+              <a:t xml:space="preserve"> ← البعد البيئي والبشري (سلامة المواد) والمؤسسي (أكواد التدوير و FSC).</a:t>
+            </a:r>
+            <a:endParaRPr lang="ar-SA" sz="2000" dirty="0"/>
+          </a:p>
+          <a:p>
+            <a:pPr marL="0" indent="0">
+              <a:buNone/>
+            </a:pPr>
+            <a:r>
+              <a:rPr lang="ar-SA" sz="2000" dirty="0"/>
+              <a:t xml:space="preserve">• </a:t>
+            </a:r>
+            <a:r>
+              <a:rPr lang="ar-SA" sz="2000" b="1" dirty="0"/>
+              <a:t>ثالثاً: الابتكارات الناشئة</a:t>
+            </a:r>
+            <a:r>
+              <a:rPr lang="ar-SA" sz="2000" dirty="0"/>
+              <a:t xml:space="preserve"> ← البعد البيئي والاجتماعي (تغيير سلوك المستهلك).</a:t>
+            </a:r>
+            <a:endParaRPr lang="ar-SA" sz="2000" dirty="0"/>
+          </a:p>
+          <a:p>
+            <a:pPr marL="0" indent="0">
+              <a:buNone/>
+            </a:pPr>
+            <a:r>
+              <a:rPr lang="ar-SA" sz="2000" dirty="0"/>
+              <a:t xml:space="preserve">• </a:t>
+            </a:r>
+            <a:r>
+              <a:rPr lang="ar-SA" sz="2000" b="1" dirty="0"/>
+              <a:t>رابعاً: التغليف متعدد الاستخدامات</a:t>
+            </a:r>
+            <a:r>
+              <a:rPr lang="ar-SA" sz="2000" dirty="0"/>
+              <a:t xml:space="preserve"> ← البعد الاقتصادي والاجتماعي والثقافي.</a:t>
+            </a:r>
+            <a:endParaRPr lang="ar-SA" sz="2000" dirty="0"/>
+          </a:p>
+          <a:p>
+            <a:pPr marL="0" indent="0">
+              <a:buNone/>
+            </a:pPr>
+            <a:r>
+              <a:rPr lang="ar-SA" sz="2000" dirty="0"/>
+              <a:t xml:space="preserve">ونبدأ بأول وأهم قاعدة يعتمد عليها مصمم العبوات: </a:t>
+            </a:r>
+            <a:r>
+              <a:rPr lang="ar-SA" sz="2000" b="1" dirty="0"/>
+              <a:t>هرم إدارة النفايات</a:t>
+            </a:r>
+            <a:r>
+              <a:rPr lang="ar-SA" sz="2000" dirty="0"/>
+              <a:t>.</a:t>
+            </a:r>
+            <a:endParaRPr lang="ar-SA" sz="2000" dirty="0"/>
+          </a:p>
+        </p:txBody>
+      </p:sp>
+      <p:pic>
+        <p:nvPicPr>
+          <p:cNvPr id="4" name="Picture 3" descr="رسم توضيحي: طريق متعرج بأربع محطات مرقمة ينتهي بعبوة تنبت منها نبتة">
+            <a:extLst>
+              <a:ext uri="{FF2B5EF4-FFF2-40B4-BE49-F238E27FC236}">
+                <a16:creationId xmlns:a16="http://schemas.microsoft.com/office/drawing/2014/main" id="{056553AD-C0DE-E827-1CFB-B6851E4E9DCC}"/>
+              </a:ext>
+            </a:extLst>
+          </p:cNvPr>
+          <p:cNvPicPr>
+            <a:picLocks noChangeAspect="1"/>
+          </p:cNvPicPr>
+          <p:nvPr/>
+        </p:nvPicPr>
+        <p:blipFill>
+          <a:blip r:embed="rId2"/>
+          <a:stretch>
+            <a:fillRect/>
+          </a:stretch>
+        </p:blipFill>
+        <p:spPr>
+          <a:xfrm>
+            <a:off x="680000" y="1500000"/>
+            <a:ext cx="3200400" cy="4267200"/>
+          </a:xfrm>
+          <a:prstGeom prst="rect">
+            <a:avLst/>
+          </a:prstGeom>
+        </p:spPr>
+      </p:pic>
+    </p:spTree>
+    <p:extLst>
+      <p:ext uri="{BB962C8B-B14F-4D97-AF65-F5344CB8AC3E}">
+        <p14:creationId xmlns:p14="http://schemas.microsoft.com/office/powerpoint/2010/main" val="3458178417"/>
+      </p:ext>
+    </p:extLst>
+  </p:cSld>
+  <p:clrMapOvr>
+    <a:masterClrMapping/>
+  </p:clrMapOvr>
+</p:sld>
+</file>
+
+<file path=ppt/slides/slide17.xml><?xml version="1.0" encoding="utf-8"?>
+<p:sld xmlns:a="http://schemas.openxmlformats.org/drawingml/2006/main" xmlns:r="http://schemas.openxmlformats.org/officeDocument/2006/relationships" xmlns:p="http://schemas.openxmlformats.org/presentationml/2006/main">
+  <p:cSld>
+    <p:spTree>
+      <p:nvGrpSpPr>
+        <p:cNvPr id="1" name="">
+          <a:extLst>
+            <a:ext uri="{FF2B5EF4-FFF2-40B4-BE49-F238E27FC236}">
               <a16:creationId xmlns:a16="http://schemas.microsoft.com/office/drawing/2014/main" id="{F7C2DB49-E0CB-E0AD-4519-280914AEE6EF}"/>
             </a:ext>
           </a:extLst>
@@ -7667,7 +8079,7 @@
 </p:sld>
 </file>
 
-<file path=ppt/slides/slide17.xml><?xml version="1.0" encoding="utf-8"?>
+<file path=ppt/slides/slide18.xml><?xml version="1.0" encoding="utf-8"?>
 <p:sld xmlns:a="http://schemas.openxmlformats.org/drawingml/2006/main" xmlns:r="http://schemas.openxmlformats.org/officeDocument/2006/relationships" xmlns:p="http://schemas.openxmlformats.org/presentationml/2006/main">
   <p:cSld>
     <p:spTree>

</xml_diff>

<commit_message>
Link intro, dimension slides and original sections; add synthesis slide
Co-Authored-By: Claude Opus 5.5 <noreply@anthropic.com>
Claude-Session: https://claude.ai/code/session_015QQoGwFQ5zRfCX9EMYaD2s
</commit_message>
<xml_diff>
--- a/lectures/التصميم_المستدام_الجزء_الثاني_موسع.pptx
+++ b/lectures/التصميم_المستدام_الجزء_الثاني_موسع.pptx
@@ -29,6 +29,7 @@
     <p:sldId id="289" r:id="rId10"/>
     <p:sldId id="297" r:id="rId24"/>
     <p:sldId id="298" r:id="rId25"/>
+    <p:sldId id="299" r:id="rId26"/>
   </p:sldIdLst>
   <p:sldSz cx="12192000" cy="6858000"/>
   <p:notesSz cx="6858000" cy="9144000"/>
@@ -5600,6 +5601,99 @@
           </a:prstGeom>
         </p:spPr>
       </p:pic>
+      <p:sp>
+        <p:nvSpPr>
+          <p:cNvPr id="901" name="Dimension Badge" descr="نطبّقه في المحاضرة: أولاً، ثانياً، ثالثاً"/>
+          <p:cNvSpPr/>
+          <p:nvPr/>
+        </p:nvSpPr>
+        <p:spPr>
+          <a:xfrm>
+            <a:off x="4150000" y="520000"/>
+            <a:ext cx="5600000" cy="400000"/>
+          </a:xfrm>
+          <a:prstGeom prst="roundRect">
+            <a:avLst>
+              <a:gd name="adj" fmla="val 50000"/>
+            </a:avLst>
+          </a:prstGeom>
+          <a:solidFill>
+            <a:srgbClr val="F6F1E7"/>
+          </a:solidFill>
+          <a:ln>
+            <a:noFill/>
+          </a:ln>
+        </p:spPr>
+        <p:txBody>
+          <a:bodyPr wrap="none" lIns="182880" rIns="182880" tIns="0" bIns="0" anchor="ctr" rtlCol="1">
+            <a:noAutofit/>
+          </a:bodyPr>
+          <a:lstStyle/>
+          <a:p>
+            <a:pPr algn="r" rtl="1"/>
+            <a:r>
+              <a:rPr lang="ar-SA" sz="1600" dirty="0">
+                <a:solidFill>
+                  <a:srgbClr val="4A3B2A"/>
+                </a:solidFill>
+                <a:latin typeface="Sakkal Majalla"/>
+                <a:cs typeface="Sakkal Majalla"/>
+              </a:rPr>
+              <a:t xml:space="preserve">نطبّقه في المحاضرة: </a:t>
+            </a:r>
+            <a:r>
+              <a:rPr lang="ar-SA" sz="1600" b="1" dirty="0">
+                <a:solidFill>
+                  <a:srgbClr val="4A3B2A"/>
+                </a:solidFill>
+                <a:latin typeface="Sakkal Majalla"/>
+                <a:cs typeface="Sakkal Majalla"/>
+              </a:rPr>
+              <a:t>أولاً</a:t>
+            </a:r>
+            <a:r>
+              <a:rPr lang="ar-SA" sz="1600" dirty="0">
+                <a:solidFill>
+                  <a:srgbClr val="4A3B2A"/>
+                </a:solidFill>
+                <a:latin typeface="Sakkal Majalla"/>
+                <a:cs typeface="Sakkal Majalla"/>
+              </a:rPr>
+              <a:t xml:space="preserve"> • </a:t>
+            </a:r>
+            <a:r>
+              <a:rPr lang="ar-SA" sz="1600" b="1" dirty="0">
+                <a:solidFill>
+                  <a:srgbClr val="4A3B2A"/>
+                </a:solidFill>
+                <a:latin typeface="Sakkal Majalla"/>
+                <a:cs typeface="Sakkal Majalla"/>
+              </a:rPr>
+              <a:t>ثانياً</a:t>
+            </a:r>
+            <a:r>
+              <a:rPr lang="ar-SA" sz="1600" dirty="0">
+                <a:solidFill>
+                  <a:srgbClr val="4A3B2A"/>
+                </a:solidFill>
+                <a:latin typeface="Sakkal Majalla"/>
+                <a:cs typeface="Sakkal Majalla"/>
+              </a:rPr>
+              <a:t xml:space="preserve"> • </a:t>
+            </a:r>
+            <a:r>
+              <a:rPr lang="ar-SA" sz="1600" b="1" dirty="0">
+                <a:solidFill>
+                  <a:srgbClr val="4A3B2A"/>
+                </a:solidFill>
+                <a:latin typeface="Sakkal Majalla"/>
+                <a:cs typeface="Sakkal Majalla"/>
+              </a:rPr>
+              <a:t>ثالثاً</a:t>
+            </a:r>
+          </a:p>
+        </p:txBody>
+      </p:sp>
     </p:spTree>
     <p:extLst>
       <p:ext uri="{BB962C8B-B14F-4D97-AF65-F5344CB8AC3E}">
@@ -6019,6 +6113,79 @@
           </a:prstGeom>
         </p:spPr>
       </p:pic>
+      <p:sp>
+        <p:nvSpPr>
+          <p:cNvPr id="902" name="Dimension Badge" descr="نطبّقه في المحاضرة: أولاً، رابعاً"/>
+          <p:cNvSpPr/>
+          <p:nvPr/>
+        </p:nvSpPr>
+        <p:spPr>
+          <a:xfrm>
+            <a:off x="4150000" y="520000"/>
+            <a:ext cx="5600000" cy="400000"/>
+          </a:xfrm>
+          <a:prstGeom prst="roundRect">
+            <a:avLst>
+              <a:gd name="adj" fmla="val 50000"/>
+            </a:avLst>
+          </a:prstGeom>
+          <a:solidFill>
+            <a:srgbClr val="F6F1E7"/>
+          </a:solidFill>
+          <a:ln>
+            <a:noFill/>
+          </a:ln>
+        </p:spPr>
+        <p:txBody>
+          <a:bodyPr wrap="none" lIns="182880" rIns="182880" tIns="0" bIns="0" anchor="ctr" rtlCol="1">
+            <a:noAutofit/>
+          </a:bodyPr>
+          <a:lstStyle/>
+          <a:p>
+            <a:pPr algn="r" rtl="1"/>
+            <a:r>
+              <a:rPr lang="ar-SA" sz="1600" dirty="0">
+                <a:solidFill>
+                  <a:srgbClr val="4A3B2A"/>
+                </a:solidFill>
+                <a:latin typeface="Sakkal Majalla"/>
+                <a:cs typeface="Sakkal Majalla"/>
+              </a:rPr>
+              <a:t xml:space="preserve">نطبّقه في المحاضرة: </a:t>
+            </a:r>
+            <a:r>
+              <a:rPr lang="ar-SA" sz="1600" b="1" dirty="0">
+                <a:solidFill>
+                  <a:srgbClr val="4A3B2A"/>
+                </a:solidFill>
+                <a:latin typeface="Sakkal Majalla"/>
+                <a:cs typeface="Sakkal Majalla"/>
+              </a:rPr>
+              <a:t>أولاً</a:t>
+            </a:r>
+            <a:r>
+              <a:rPr lang="ar-SA" sz="1600" dirty="0">
+                <a:solidFill>
+                  <a:srgbClr val="4A3B2A"/>
+                </a:solidFill>
+                <a:latin typeface="Sakkal Majalla"/>
+                <a:cs typeface="Sakkal Majalla"/>
+              </a:rPr>
+              <a:t xml:space="preserve"> • </a:t>
+            </a:r>
+            <a:r>
+              <a:rPr lang="ar-SA" sz="1600" b="1" dirty="0">
+                <a:solidFill>
+                  <a:srgbClr val="4A3B2A"/>
+                </a:solidFill>
+                <a:latin typeface="Sakkal Majalla"/>
+                <a:cs typeface="Sakkal Majalla"/>
+              </a:rPr>
+              <a:t>رابعاً</a:t>
+            </a:r>
+          </a:p>
+        </p:txBody>
+      </p:sp>
     </p:spTree>
     <p:extLst>
       <p:ext uri="{BB962C8B-B14F-4D97-AF65-F5344CB8AC3E}">
@@ -6434,6 +6601,79 @@
           </a:prstGeom>
         </p:spPr>
       </p:pic>
+      <p:sp>
+        <p:nvSpPr>
+          <p:cNvPr id="903" name="Dimension Badge" descr="نطبّقه في المحاضرة: ثالثاً، رابعاً"/>
+          <p:cNvSpPr/>
+          <p:nvPr/>
+        </p:nvSpPr>
+        <p:spPr>
+          <a:xfrm>
+            <a:off x="4150000" y="520000"/>
+            <a:ext cx="5600000" cy="400000"/>
+          </a:xfrm>
+          <a:prstGeom prst="roundRect">
+            <a:avLst>
+              <a:gd name="adj" fmla="val 50000"/>
+            </a:avLst>
+          </a:prstGeom>
+          <a:solidFill>
+            <a:srgbClr val="F6F1E7"/>
+          </a:solidFill>
+          <a:ln>
+            <a:noFill/>
+          </a:ln>
+        </p:spPr>
+        <p:txBody>
+          <a:bodyPr wrap="none" lIns="182880" rIns="182880" tIns="0" bIns="0" anchor="ctr" rtlCol="1">
+            <a:noAutofit/>
+          </a:bodyPr>
+          <a:lstStyle/>
+          <a:p>
+            <a:pPr algn="r" rtl="1"/>
+            <a:r>
+              <a:rPr lang="ar-SA" sz="1600" dirty="0">
+                <a:solidFill>
+                  <a:srgbClr val="4A3B2A"/>
+                </a:solidFill>
+                <a:latin typeface="Sakkal Majalla"/>
+                <a:cs typeface="Sakkal Majalla"/>
+              </a:rPr>
+              <a:t xml:space="preserve">نطبّقه في المحاضرة: </a:t>
+            </a:r>
+            <a:r>
+              <a:rPr lang="ar-SA" sz="1600" b="1" dirty="0">
+                <a:solidFill>
+                  <a:srgbClr val="4A3B2A"/>
+                </a:solidFill>
+                <a:latin typeface="Sakkal Majalla"/>
+                <a:cs typeface="Sakkal Majalla"/>
+              </a:rPr>
+              <a:t>ثالثاً</a:t>
+            </a:r>
+            <a:r>
+              <a:rPr lang="ar-SA" sz="1600" dirty="0">
+                <a:solidFill>
+                  <a:srgbClr val="4A3B2A"/>
+                </a:solidFill>
+                <a:latin typeface="Sakkal Majalla"/>
+                <a:cs typeface="Sakkal Majalla"/>
+              </a:rPr>
+              <a:t xml:space="preserve"> • </a:t>
+            </a:r>
+            <a:r>
+              <a:rPr lang="ar-SA" sz="1600" b="1" dirty="0">
+                <a:solidFill>
+                  <a:srgbClr val="4A3B2A"/>
+                </a:solidFill>
+                <a:latin typeface="Sakkal Majalla"/>
+                <a:cs typeface="Sakkal Majalla"/>
+              </a:rPr>
+              <a:t>رابعاً</a:t>
+            </a:r>
+          </a:p>
+        </p:txBody>
+      </p:sp>
     </p:spTree>
     <p:extLst>
       <p:ext uri="{BB962C8B-B14F-4D97-AF65-F5344CB8AC3E}">
@@ -6853,6 +7093,59 @@
           </a:prstGeom>
         </p:spPr>
       </p:pic>
+      <p:sp>
+        <p:nvSpPr>
+          <p:cNvPr id="904" name="Dimension Badge" descr="نطبّقه في المحاضرة: رابعاً"/>
+          <p:cNvSpPr/>
+          <p:nvPr/>
+        </p:nvSpPr>
+        <p:spPr>
+          <a:xfrm>
+            <a:off x="4150000" y="520000"/>
+            <a:ext cx="5600000" cy="400000"/>
+          </a:xfrm>
+          <a:prstGeom prst="roundRect">
+            <a:avLst>
+              <a:gd name="adj" fmla="val 50000"/>
+            </a:avLst>
+          </a:prstGeom>
+          <a:solidFill>
+            <a:srgbClr val="F6F1E7"/>
+          </a:solidFill>
+          <a:ln>
+            <a:noFill/>
+          </a:ln>
+        </p:spPr>
+        <p:txBody>
+          <a:bodyPr wrap="none" lIns="182880" rIns="182880" tIns="0" bIns="0" anchor="ctr" rtlCol="1">
+            <a:noAutofit/>
+          </a:bodyPr>
+          <a:lstStyle/>
+          <a:p>
+            <a:pPr algn="r" rtl="1"/>
+            <a:r>
+              <a:rPr lang="ar-SA" sz="1600" dirty="0">
+                <a:solidFill>
+                  <a:srgbClr val="4A3B2A"/>
+                </a:solidFill>
+                <a:latin typeface="Sakkal Majalla"/>
+                <a:cs typeface="Sakkal Majalla"/>
+              </a:rPr>
+              <a:t xml:space="preserve">نطبّقه في المحاضرة: </a:t>
+            </a:r>
+            <a:r>
+              <a:rPr lang="ar-SA" sz="1600" b="1" dirty="0">
+                <a:solidFill>
+                  <a:srgbClr val="4A3B2A"/>
+                </a:solidFill>
+                <a:latin typeface="Sakkal Majalla"/>
+                <a:cs typeface="Sakkal Majalla"/>
+              </a:rPr>
+              <a:t>رابعاً</a:t>
+            </a:r>
+          </a:p>
+        </p:txBody>
+      </p:sp>
     </p:spTree>
     <p:extLst>
       <p:ext uri="{BB962C8B-B14F-4D97-AF65-F5344CB8AC3E}">
@@ -7292,6 +7585,59 @@
           </a:prstGeom>
         </p:spPr>
       </p:pic>
+      <p:sp>
+        <p:nvSpPr>
+          <p:cNvPr id="905" name="Dimension Badge" descr="نطبّقه في المحاضرة: ثانياً"/>
+          <p:cNvSpPr/>
+          <p:nvPr/>
+        </p:nvSpPr>
+        <p:spPr>
+          <a:xfrm>
+            <a:off x="4150000" y="520000"/>
+            <a:ext cx="5600000" cy="400000"/>
+          </a:xfrm>
+          <a:prstGeom prst="roundRect">
+            <a:avLst>
+              <a:gd name="adj" fmla="val 50000"/>
+            </a:avLst>
+          </a:prstGeom>
+          <a:solidFill>
+            <a:srgbClr val="F6F1E7"/>
+          </a:solidFill>
+          <a:ln>
+            <a:noFill/>
+          </a:ln>
+        </p:spPr>
+        <p:txBody>
+          <a:bodyPr wrap="none" lIns="182880" rIns="182880" tIns="0" bIns="0" anchor="ctr" rtlCol="1">
+            <a:noAutofit/>
+          </a:bodyPr>
+          <a:lstStyle/>
+          <a:p>
+            <a:pPr algn="r" rtl="1"/>
+            <a:r>
+              <a:rPr lang="ar-SA" sz="1600" dirty="0">
+                <a:solidFill>
+                  <a:srgbClr val="4A3B2A"/>
+                </a:solidFill>
+                <a:latin typeface="Sakkal Majalla"/>
+                <a:cs typeface="Sakkal Majalla"/>
+              </a:rPr>
+              <a:t xml:space="preserve">نطبّقه في المحاضرة: </a:t>
+            </a:r>
+            <a:r>
+              <a:rPr lang="ar-SA" sz="1600" b="1" dirty="0">
+                <a:solidFill>
+                  <a:srgbClr val="4A3B2A"/>
+                </a:solidFill>
+                <a:latin typeface="Sakkal Majalla"/>
+                <a:cs typeface="Sakkal Majalla"/>
+              </a:rPr>
+              <a:t>ثانياً</a:t>
+            </a:r>
+          </a:p>
+        </p:txBody>
+      </p:sp>
     </p:spTree>
     <p:extLst>
       <p:ext uri="{BB962C8B-B14F-4D97-AF65-F5344CB8AC3E}">
@@ -7789,8 +8135,8 @@
         </p:nvSpPr>
         <p:spPr>
           <a:xfrm>
-            <a:off x="874845" y="1416963"/>
-            <a:ext cx="10442309" cy="1030380"/>
+            <a:off x="874845" y="1300000"/>
+            <a:ext cx="10442309" cy="800000"/>
           </a:xfrm>
           <a:prstGeom prst="rect">
             <a:avLst/>
@@ -7970,102 +8316,634 @@
             </a:pPr>
             <a:r>
               <a:rPr lang="ar-SA" sz="2000" b="1" dirty="0"/>
-              <a:t>المصادر والمراجع</a:t>
+              <a:t>الخلاصة: كيف تتكامل أبعاد الاستدامة في تصميم المغلفات؟</a:t>
             </a:r>
             <a:endParaRPr lang="ar-SA" sz="2000" dirty="0"/>
           </a:p>
           <a:p>
-            <a:pPr marL="0" indent="0" algn="l" rtl="0">
+            <a:pPr marL="0" indent="0">
               <a:buNone/>
             </a:pPr>
             <a:r>
-              <a:rPr lang="en-US" sz="1600" dirty="0"/>
-              <a:t>Boylston, S. (2009). Designing sustainable packaging. Laurence King Publishing.</a:t>
-            </a:r>
-            <a:endParaRPr lang="en-US" sz="1600" dirty="0"/>
-          </a:p>
-          <a:p>
-            <a:pPr marL="0" indent="0" algn="l" rtl="0">
-              <a:buNone/>
-            </a:pPr>
-            <a:r>
-              <a:rPr lang="en-US" sz="1600" dirty="0"/>
-              <a:t>Jedlička, W. (2009). Packaging sustainability: Tools, systems and strategies for innovative package design. John Wiley &amp; Sons.</a:t>
-            </a:r>
-            <a:endParaRPr lang="en-US" sz="1600" dirty="0"/>
-          </a:p>
-          <a:p>
-            <a:pPr marL="0" indent="0" algn="l" rtl="0">
-              <a:buNone/>
-            </a:pPr>
-            <a:r>
-              <a:rPr lang="en-US" sz="1600" dirty="0"/>
-              <a:t>World Commission on Environment and Development. (1987). Our common future. Oxford University Press.</a:t>
-            </a:r>
-            <a:endParaRPr lang="en-US" sz="1600" dirty="0"/>
-          </a:p>
-          <a:p>
-            <a:pPr marL="0" indent="0" algn="l" rtl="0">
-              <a:buNone/>
-            </a:pPr>
-            <a:r>
-              <a:rPr lang="en-US" sz="1600" dirty="0"/>
-              <a:t>Elkington, J. (1997). Cannibals with forks: The triple bottom line of 21st century business. Capstone.</a:t>
-            </a:r>
-            <a:endParaRPr lang="en-US" sz="1600" dirty="0"/>
-          </a:p>
-          <a:p>
-            <a:pPr marL="0" indent="0" algn="l" rtl="0">
-              <a:buNone/>
-            </a:pPr>
-            <a:r>
-              <a:rPr lang="en-US" sz="1600" dirty="0"/>
-              <a:t>Hawkes, J. (2001). The fourth pillar of sustainability: Culture's essential role in public planning. Common Ground / Cultural Development Network.</a:t>
-            </a:r>
-            <a:endParaRPr lang="en-US" sz="1600" dirty="0"/>
-          </a:p>
-          <a:p>
-            <a:pPr marL="0" indent="0" algn="l" rtl="0">
-              <a:buNone/>
-            </a:pPr>
-            <a:r>
-              <a:rPr lang="en-US" sz="1600" dirty="0"/>
-              <a:t>United Cities and Local Governments (UCLG). (2010). Culture: Fourth pillar of sustainable development. UCLG.</a:t>
-            </a:r>
-            <a:endParaRPr lang="en-US" sz="1600" dirty="0"/>
-          </a:p>
-          <a:p>
-            <a:pPr marL="0" indent="0" algn="l" rtl="0">
-              <a:buNone/>
-            </a:pPr>
-            <a:r>
-              <a:rPr lang="en-US" sz="1600" dirty="0"/>
-              <a:t>Goodland, R. (2002). Sustainability: Human, social, economic and environmental. In Encyclopedia of global environmental change. John Wiley &amp; Sons.</a:t>
-            </a:r>
-            <a:endParaRPr lang="en-US" sz="1600" dirty="0"/>
-          </a:p>
-          <a:p>
-            <a:pPr marL="0" indent="0" algn="l" rtl="0">
-              <a:buNone/>
-            </a:pPr>
-            <a:r>
-              <a:rPr lang="en-US" sz="1600" dirty="0"/>
-              <a:t>United Nations. (2001). Indicators of sustainable development: Guidelines and methodologies (2nd ed.). UN DESA.</a:t>
-            </a:r>
-            <a:endParaRPr lang="en-US" sz="1600" dirty="0"/>
-          </a:p>
-          <a:p>
-            <a:pPr marL="0" indent="0" algn="l" rtl="0">
-              <a:buNone/>
-            </a:pPr>
-            <a:r>
-              <a:rPr lang="en-US" sz="1600" dirty="0"/>
-              <a:t>United Nations. (2015). Transforming our world: The 2030 Agenda for Sustainable Development (A/RES/70/1).</a:t>
-            </a:r>
-            <a:endParaRPr lang="en-US" sz="1600" dirty="0"/>
+              <a:rPr lang="ar-SA" sz="2000" dirty="0"/>
+              <a:t>كل قرار في العبوة يخدم أكثر من بُعد؛ وهذا الجدول يربط الأبعاد بما درسناه:</a:t>
+            </a:r>
+            <a:endParaRPr lang="ar-SA" sz="2000" dirty="0"/>
           </a:p>
         </p:txBody>
       </p:sp>
+      <p:graphicFrame>
+        <p:nvGraphicFramePr>
+          <p:cNvPr id="913" name="Synthesis Table"/>
+          <p:cNvGraphicFramePr>
+            <a:graphicFrameLocks noGrp="1"/>
+          </p:cNvGraphicFramePr>
+          <p:nvPr/>
+        </p:nvGraphicFramePr>
+        <p:xfrm>
+          <a:off x="874845" y="2250000"/>
+          <a:ext cx="10442309" cy="3500000"/>
+        </p:xfrm>
+        <a:graphic>
+          <a:graphicData uri="http://schemas.openxmlformats.org/drawingml/2006/table">
+            <a:tbl>
+              <a:tblPr rtl="1" firstRow="1"/>
+              <a:tblGrid>
+                <a:gridCol w="2000000"/>
+                <a:gridCol w="2800000"/>
+                <a:gridCol w="5642309"/>
+              </a:tblGrid>
+              <a:tr h="500000">
+                <a:tc>
+                  <a:txBody>
+                    <a:bodyPr/>
+                    <a:lstStyle/>
+                    <a:p>
+                      <a:pPr algn="r" rtl="1"/>
+                      <a:r>
+                        <a:rPr lang="ar-SA" sz="1600" b="1" dirty="0">
+                          <a:solidFill>
+                            <a:srgbClr val="FFFFFF"/>
+                          </a:solidFill>
+                          <a:latin typeface="Sakkal Majalla"/>
+                          <a:cs typeface="Sakkal Majalla"/>
+                        </a:rPr>
+                        <a:t>البُعد</a:t>
+                      </a:r>
+                    </a:p>
+                  </a:txBody>
+                  <a:tcPr marL="91440" marR="91440" marT="45720" marB="45720" anchor="ctr">
+                    <a:lnB w="6350">
+                      <a:solidFill>
+                        <a:srgbClr val="D9CBB0"/>
+                      </a:solidFill>
+                    </a:lnB>
+                    <a:solidFill>
+                      <a:srgbClr val="6B5235"/>
+                    </a:solidFill>
+                  </a:tcPr>
+                </a:tc>
+                <a:tc>
+                  <a:txBody>
+                    <a:bodyPr/>
+                    <a:lstStyle/>
+                    <a:p>
+                      <a:pPr algn="r" rtl="1"/>
+                      <a:r>
+                        <a:rPr lang="ar-SA" sz="1600" b="1" dirty="0">
+                          <a:solidFill>
+                            <a:srgbClr val="FFFFFF"/>
+                          </a:solidFill>
+                          <a:latin typeface="Sakkal Majalla"/>
+                          <a:cs typeface="Sakkal Majalla"/>
+                        </a:rPr>
+                        <a:t>أين طبّقناه في المحاضرة؟</a:t>
+                      </a:r>
+                    </a:p>
+                  </a:txBody>
+                  <a:tcPr marL="91440" marR="91440" marT="45720" marB="45720" anchor="ctr">
+                    <a:lnB w="6350">
+                      <a:solidFill>
+                        <a:srgbClr val="D9CBB0"/>
+                      </a:solidFill>
+                    </a:lnB>
+                    <a:solidFill>
+                      <a:srgbClr val="6B5235"/>
+                    </a:solidFill>
+                  </a:tcPr>
+                </a:tc>
+                <a:tc>
+                  <a:txBody>
+                    <a:bodyPr/>
+                    <a:lstStyle/>
+                    <a:p>
+                      <a:pPr algn="r" rtl="1"/>
+                      <a:r>
+                        <a:rPr lang="ar-SA" sz="1600" b="1" dirty="0">
+                          <a:solidFill>
+                            <a:srgbClr val="FFFFFF"/>
+                          </a:solidFill>
+                          <a:latin typeface="Sakkal Majalla"/>
+                          <a:cs typeface="Sakkal Majalla"/>
+                        </a:rPr>
+                        <a:t>أهم قرار تصميمي</a:t>
+                      </a:r>
+                    </a:p>
+                  </a:txBody>
+                  <a:tcPr marL="91440" marR="91440" marT="45720" marB="45720" anchor="ctr">
+                    <a:lnB w="6350">
+                      <a:solidFill>
+                        <a:srgbClr val="D9CBB0"/>
+                      </a:solidFill>
+                    </a:lnB>
+                    <a:solidFill>
+                      <a:srgbClr val="6B5235"/>
+                    </a:solidFill>
+                  </a:tcPr>
+                </a:tc>
+              </a:tr>
+              <a:tr h="500000">
+                <a:tc>
+                  <a:txBody>
+                    <a:bodyPr/>
+                    <a:lstStyle/>
+                    <a:p>
+                      <a:pPr algn="r" rtl="1"/>
+                      <a:r>
+                        <a:rPr lang="ar-SA" sz="1600" b="1" dirty="0">
+                          <a:solidFill>
+                            <a:srgbClr val="5E9C4B"/>
+                          </a:solidFill>
+                          <a:latin typeface="Sakkal Majalla"/>
+                          <a:cs typeface="Sakkal Majalla"/>
+                        </a:rPr>
+                        <a:t>البيئي</a:t>
+                      </a:r>
+                    </a:p>
+                  </a:txBody>
+                  <a:tcPr marL="91440" marR="91440" marT="45720" marB="45720" anchor="ctr">
+                    <a:lnB w="6350">
+                      <a:solidFill>
+                        <a:srgbClr val="D9CBB0"/>
+                      </a:solidFill>
+                    </a:lnB>
+                    <a:noFill/>
+                  </a:tcPr>
+                </a:tc>
+                <a:tc>
+                  <a:txBody>
+                    <a:bodyPr/>
+                    <a:lstStyle/>
+                    <a:p>
+                      <a:pPr algn="r" rtl="1"/>
+                      <a:r>
+                        <a:rPr lang="ar-SA" sz="1600" dirty="0">
+                          <a:solidFill>
+                            <a:srgbClr val="262626"/>
+                          </a:solidFill>
+                          <a:latin typeface="Sakkal Majalla"/>
+                          <a:cs typeface="Sakkal Majalla"/>
+                        </a:rPr>
+                        <a:t>أولاً، ثانياً، ثالثاً</a:t>
+                      </a:r>
+                    </a:p>
+                  </a:txBody>
+                  <a:tcPr marL="91440" marR="91440" marT="45720" marB="45720" anchor="ctr">
+                    <a:lnB w="6350">
+                      <a:solidFill>
+                        <a:srgbClr val="D9CBB0"/>
+                      </a:solidFill>
+                    </a:lnB>
+                    <a:noFill/>
+                  </a:tcPr>
+                </a:tc>
+                <a:tc>
+                  <a:txBody>
+                    <a:bodyPr/>
+                    <a:lstStyle/>
+                    <a:p>
+                      <a:pPr algn="r" rtl="1"/>
+                      <a:r>
+                        <a:rPr lang="ar-SA" sz="1600" dirty="0">
+                          <a:solidFill>
+                            <a:srgbClr val="262626"/>
+                          </a:solidFill>
+                          <a:latin typeface="Sakkal Majalla"/>
+                          <a:cs typeface="Sakkal Majalla"/>
+                        </a:rPr>
+                        <a:t>مواد أقل، أحادية، قابلة للتدوير أو التحلل الحيوي</a:t>
+                      </a:r>
+                    </a:p>
+                  </a:txBody>
+                  <a:tcPr marL="91440" marR="91440" marT="45720" marB="45720" anchor="ctr">
+                    <a:lnB w="6350">
+                      <a:solidFill>
+                        <a:srgbClr val="D9CBB0"/>
+                      </a:solidFill>
+                    </a:lnB>
+                    <a:noFill/>
+                  </a:tcPr>
+                </a:tc>
+              </a:tr>
+              <a:tr h="500000">
+                <a:tc>
+                  <a:txBody>
+                    <a:bodyPr/>
+                    <a:lstStyle/>
+                    <a:p>
+                      <a:pPr algn="r" rtl="1"/>
+                      <a:r>
+                        <a:rPr lang="ar-SA" sz="1600" b="1" dirty="0">
+                          <a:solidFill>
+                            <a:srgbClr val="D9A441"/>
+                          </a:solidFill>
+                          <a:latin typeface="Sakkal Majalla"/>
+                          <a:cs typeface="Sakkal Majalla"/>
+                        </a:rPr>
+                        <a:t>الاقتصادي</a:t>
+                      </a:r>
+                    </a:p>
+                  </a:txBody>
+                  <a:tcPr marL="91440" marR="91440" marT="45720" marB="45720" anchor="ctr">
+                    <a:lnB w="6350">
+                      <a:solidFill>
+                        <a:srgbClr val="D9CBB0"/>
+                      </a:solidFill>
+                    </a:lnB>
+                    <a:noFill/>
+                  </a:tcPr>
+                </a:tc>
+                <a:tc>
+                  <a:txBody>
+                    <a:bodyPr/>
+                    <a:lstStyle/>
+                    <a:p>
+                      <a:pPr algn="r" rtl="1"/>
+                      <a:r>
+                        <a:rPr lang="ar-SA" sz="1600" dirty="0">
+                          <a:solidFill>
+                            <a:srgbClr val="262626"/>
+                          </a:solidFill>
+                          <a:latin typeface="Sakkal Majalla"/>
+                          <a:cs typeface="Sakkal Majalla"/>
+                        </a:rPr>
+                        <a:t>أولاً، رابعاً</a:t>
+                      </a:r>
+                    </a:p>
+                  </a:txBody>
+                  <a:tcPr marL="91440" marR="91440" marT="45720" marB="45720" anchor="ctr">
+                    <a:lnB w="6350">
+                      <a:solidFill>
+                        <a:srgbClr val="D9CBB0"/>
+                      </a:solidFill>
+                    </a:lnB>
+                    <a:noFill/>
+                  </a:tcPr>
+                </a:tc>
+                <a:tc>
+                  <a:txBody>
+                    <a:bodyPr/>
+                    <a:lstStyle/>
+                    <a:p>
+                      <a:pPr algn="r" rtl="1"/>
+                      <a:r>
+                        <a:rPr lang="ar-SA" sz="1600" dirty="0">
+                          <a:solidFill>
+                            <a:srgbClr val="262626"/>
+                          </a:solidFill>
+                          <a:latin typeface="Sakkal Majalla"/>
+                          <a:cs typeface="Sakkal Majalla"/>
+                        </a:rPr>
+                        <a:t>تخفيف الوزن، الشحن المسطح، عبوة لها حياة ثانية</a:t>
+                      </a:r>
+                    </a:p>
+                  </a:txBody>
+                  <a:tcPr marL="91440" marR="91440" marT="45720" marB="45720" anchor="ctr">
+                    <a:lnB w="6350">
+                      <a:solidFill>
+                        <a:srgbClr val="D9CBB0"/>
+                      </a:solidFill>
+                    </a:lnB>
+                    <a:noFill/>
+                  </a:tcPr>
+                </a:tc>
+              </a:tr>
+              <a:tr h="500000">
+                <a:tc>
+                  <a:txBody>
+                    <a:bodyPr/>
+                    <a:lstStyle/>
+                    <a:p>
+                      <a:pPr algn="r" rtl="1"/>
+                      <a:r>
+                        <a:rPr lang="ar-SA" sz="1600" b="1" dirty="0">
+                          <a:solidFill>
+                            <a:srgbClr val="4B7FA8"/>
+                          </a:solidFill>
+                          <a:latin typeface="Sakkal Majalla"/>
+                          <a:cs typeface="Sakkal Majalla"/>
+                        </a:rPr>
+                        <a:t>الاجتماعي</a:t>
+                      </a:r>
+                    </a:p>
+                  </a:txBody>
+                  <a:tcPr marL="91440" marR="91440" marT="45720" marB="45720" anchor="ctr">
+                    <a:lnB w="6350">
+                      <a:solidFill>
+                        <a:srgbClr val="D9CBB0"/>
+                      </a:solidFill>
+                    </a:lnB>
+                    <a:noFill/>
+                  </a:tcPr>
+                </a:tc>
+                <a:tc>
+                  <a:txBody>
+                    <a:bodyPr/>
+                    <a:lstStyle/>
+                    <a:p>
+                      <a:pPr algn="r" rtl="1"/>
+                      <a:r>
+                        <a:rPr lang="ar-SA" sz="1600" dirty="0">
+                          <a:solidFill>
+                            <a:srgbClr val="262626"/>
+                          </a:solidFill>
+                          <a:latin typeface="Sakkal Majalla"/>
+                          <a:cs typeface="Sakkal Majalla"/>
+                        </a:rPr>
+                        <a:t>ثالثاً، رابعاً</a:t>
+                      </a:r>
+                    </a:p>
+                  </a:txBody>
+                  <a:tcPr marL="91440" marR="91440" marT="45720" marB="45720" anchor="ctr">
+                    <a:lnB w="6350">
+                      <a:solidFill>
+                        <a:srgbClr val="D9CBB0"/>
+                      </a:solidFill>
+                    </a:lnB>
+                    <a:noFill/>
+                  </a:tcPr>
+                </a:tc>
+                <a:tc>
+                  <a:txBody>
+                    <a:bodyPr/>
+                    <a:lstStyle/>
+                    <a:p>
+                      <a:pPr algn="r" rtl="1"/>
+                      <a:r>
+                        <a:rPr lang="ar-SA" sz="1600" dirty="0">
+                          <a:solidFill>
+                            <a:srgbClr val="262626"/>
+                          </a:solidFill>
+                          <a:latin typeface="Sakkal Majalla"/>
+                          <a:cs typeface="Sakkal Majalla"/>
+                        </a:rPr>
+                        <a:t>عبوة آمنة وشاملة للجميع وصادقة في ادعاءاتها</a:t>
+                      </a:r>
+                    </a:p>
+                  </a:txBody>
+                  <a:tcPr marL="91440" marR="91440" marT="45720" marB="45720" anchor="ctr">
+                    <a:lnB w="6350">
+                      <a:solidFill>
+                        <a:srgbClr val="D9CBB0"/>
+                      </a:solidFill>
+                    </a:lnB>
+                    <a:noFill/>
+                  </a:tcPr>
+                </a:tc>
+              </a:tr>
+              <a:tr h="500000">
+                <a:tc>
+                  <a:txBody>
+                    <a:bodyPr/>
+                    <a:lstStyle/>
+                    <a:p>
+                      <a:pPr algn="r" rtl="1"/>
+                      <a:r>
+                        <a:rPr lang="ar-SA" sz="1600" b="1" dirty="0">
+                          <a:solidFill>
+                            <a:srgbClr val="B5473A"/>
+                          </a:solidFill>
+                          <a:latin typeface="Sakkal Majalla"/>
+                          <a:cs typeface="Sakkal Majalla"/>
+                        </a:rPr>
+                        <a:t>الثقافي</a:t>
+                      </a:r>
+                    </a:p>
+                  </a:txBody>
+                  <a:tcPr marL="91440" marR="91440" marT="45720" marB="45720" anchor="ctr">
+                    <a:lnB w="6350">
+                      <a:solidFill>
+                        <a:srgbClr val="D9CBB0"/>
+                      </a:solidFill>
+                    </a:lnB>
+                    <a:noFill/>
+                  </a:tcPr>
+                </a:tc>
+                <a:tc>
+                  <a:txBody>
+                    <a:bodyPr/>
+                    <a:lstStyle/>
+                    <a:p>
+                      <a:pPr algn="r" rtl="1"/>
+                      <a:r>
+                        <a:rPr lang="ar-SA" sz="1600" dirty="0">
+                          <a:solidFill>
+                            <a:srgbClr val="262626"/>
+                          </a:solidFill>
+                          <a:latin typeface="Sakkal Majalla"/>
+                          <a:cs typeface="Sakkal Majalla"/>
+                        </a:rPr>
+                        <a:t>رابعاً</a:t>
+                      </a:r>
+                    </a:p>
+                  </a:txBody>
+                  <a:tcPr marL="91440" marR="91440" marT="45720" marB="45720" anchor="ctr">
+                    <a:lnB w="6350">
+                      <a:solidFill>
+                        <a:srgbClr val="D9CBB0"/>
+                      </a:solidFill>
+                    </a:lnB>
+                    <a:noFill/>
+                  </a:tcPr>
+                </a:tc>
+                <a:tc>
+                  <a:txBody>
+                    <a:bodyPr/>
+                    <a:lstStyle/>
+                    <a:p>
+                      <a:pPr algn="r" rtl="1"/>
+                      <a:r>
+                        <a:rPr lang="ar-SA" sz="1600" dirty="0">
+                          <a:solidFill>
+                            <a:srgbClr val="262626"/>
+                          </a:solidFill>
+                          <a:latin typeface="Sakkal Majalla"/>
+                          <a:cs typeface="Sakkal Majalla"/>
+                        </a:rPr>
+                        <a:t>هوية محلية: الخط العربي، السدو، الخوص وسعف النخيل</a:t>
+                      </a:r>
+                    </a:p>
+                  </a:txBody>
+                  <a:tcPr marL="91440" marR="91440" marT="45720" marB="45720" anchor="ctr">
+                    <a:lnB w="6350">
+                      <a:solidFill>
+                        <a:srgbClr val="D9CBB0"/>
+                      </a:solidFill>
+                    </a:lnB>
+                    <a:noFill/>
+                  </a:tcPr>
+                </a:tc>
+              </a:tr>
+              <a:tr h="500000">
+                <a:tc>
+                  <a:txBody>
+                    <a:bodyPr/>
+                    <a:lstStyle/>
+                    <a:p>
+                      <a:pPr algn="r" rtl="1"/>
+                      <a:r>
+                        <a:rPr lang="ar-SA" sz="1600" b="1" dirty="0">
+                          <a:solidFill>
+                            <a:srgbClr val="8A5BA8"/>
+                          </a:solidFill>
+                          <a:latin typeface="Sakkal Majalla"/>
+                          <a:cs typeface="Sakkal Majalla"/>
+                        </a:rPr>
+                        <a:t>البشري</a:t>
+                      </a:r>
+                    </a:p>
+                  </a:txBody>
+                  <a:tcPr marL="91440" marR="91440" marT="45720" marB="45720" anchor="ctr">
+                    <a:lnB w="6350">
+                      <a:solidFill>
+                        <a:srgbClr val="D9CBB0"/>
+                      </a:solidFill>
+                    </a:lnB>
+                    <a:noFill/>
+                  </a:tcPr>
+                </a:tc>
+                <a:tc>
+                  <a:txBody>
+                    <a:bodyPr/>
+                    <a:lstStyle/>
+                    <a:p>
+                      <a:pPr algn="r" rtl="1"/>
+                      <a:r>
+                        <a:rPr lang="ar-SA" sz="1600" dirty="0">
+                          <a:solidFill>
+                            <a:srgbClr val="262626"/>
+                          </a:solidFill>
+                          <a:latin typeface="Sakkal Majalla"/>
+                          <a:cs typeface="Sakkal Majalla"/>
+                        </a:rPr>
+                        <a:t>ثانياً</a:t>
+                      </a:r>
+                    </a:p>
+                  </a:txBody>
+                  <a:tcPr marL="91440" marR="91440" marT="45720" marB="45720" anchor="ctr">
+                    <a:lnB w="6350">
+                      <a:solidFill>
+                        <a:srgbClr val="D9CBB0"/>
+                      </a:solidFill>
+                    </a:lnB>
+                    <a:noFill/>
+                  </a:tcPr>
+                </a:tc>
+                <a:tc>
+                  <a:txBody>
+                    <a:bodyPr/>
+                    <a:lstStyle/>
+                    <a:p>
+                      <a:pPr algn="r" rtl="1"/>
+                      <a:r>
+                        <a:rPr lang="ar-SA" sz="1600" dirty="0">
+                          <a:solidFill>
+                            <a:srgbClr val="262626"/>
+                          </a:solidFill>
+                          <a:latin typeface="Sakkal Majalla"/>
+                          <a:cs typeface="Sakkal Majalla"/>
+                        </a:rPr>
+                        <a:t>مواد آمنة لملامسة الغذاء وتوعية المستهلك بالفرز</a:t>
+                      </a:r>
+                    </a:p>
+                  </a:txBody>
+                  <a:tcPr marL="91440" marR="91440" marT="45720" marB="45720" anchor="ctr">
+                    <a:lnB w="6350">
+                      <a:solidFill>
+                        <a:srgbClr val="D9CBB0"/>
+                      </a:solidFill>
+                    </a:lnB>
+                    <a:noFill/>
+                  </a:tcPr>
+                </a:tc>
+              </a:tr>
+              <a:tr h="500000">
+                <a:tc>
+                  <a:txBody>
+                    <a:bodyPr/>
+                    <a:lstStyle/>
+                    <a:p>
+                      <a:pPr algn="r" rtl="1"/>
+                      <a:r>
+                        <a:rPr lang="ar-SA" sz="1600" b="1" dirty="0">
+                          <a:solidFill>
+                            <a:srgbClr val="3F8F8A"/>
+                          </a:solidFill>
+                          <a:latin typeface="Sakkal Majalla"/>
+                          <a:cs typeface="Sakkal Majalla"/>
+                        </a:rPr>
+                        <a:t>المؤسسي</a:t>
+                      </a:r>
+                    </a:p>
+                  </a:txBody>
+                  <a:tcPr marL="91440" marR="91440" marT="45720" marB="45720" anchor="ctr">
+                    <a:lnB w="6350">
+                      <a:solidFill>
+                        <a:srgbClr val="D9CBB0"/>
+                      </a:solidFill>
+                    </a:lnB>
+                    <a:noFill/>
+                  </a:tcPr>
+                </a:tc>
+                <a:tc>
+                  <a:txBody>
+                    <a:bodyPr/>
+                    <a:lstStyle/>
+                    <a:p>
+                      <a:pPr algn="r" rtl="1"/>
+                      <a:r>
+                        <a:rPr lang="ar-SA" sz="1600" dirty="0">
+                          <a:solidFill>
+                            <a:srgbClr val="262626"/>
+                          </a:solidFill>
+                          <a:latin typeface="Sakkal Majalla"/>
+                          <a:cs typeface="Sakkal Majalla"/>
+                        </a:rPr>
+                        <a:t>ثانياً</a:t>
+                      </a:r>
+                    </a:p>
+                  </a:txBody>
+                  <a:tcPr marL="91440" marR="91440" marT="45720" marB="45720" anchor="ctr">
+                    <a:lnB w="6350">
+                      <a:solidFill>
+                        <a:srgbClr val="D9CBB0"/>
+                      </a:solidFill>
+                    </a:lnB>
+                    <a:noFill/>
+                  </a:tcPr>
+                </a:tc>
+                <a:tc>
+                  <a:txBody>
+                    <a:bodyPr/>
+                    <a:lstStyle/>
+                    <a:p>
+                      <a:pPr algn="r" rtl="1"/>
+                      <a:r>
+                        <a:rPr lang="ar-SA" sz="1600" dirty="0">
+                          <a:solidFill>
+                            <a:srgbClr val="262626"/>
+                          </a:solidFill>
+                          <a:latin typeface="Sakkal Majalla"/>
+                          <a:cs typeface="Sakkal Majalla"/>
+                        </a:rPr>
+                        <a:t>أكواد التدوير، شهادة FSC، ومعايير ISO</a:t>
+                      </a:r>
+                    </a:p>
+                  </a:txBody>
+                  <a:tcPr marL="91440" marR="91440" marT="45720" marB="45720" anchor="ctr">
+                    <a:lnB w="6350">
+                      <a:solidFill>
+                        <a:srgbClr val="D9CBB0"/>
+                      </a:solidFill>
+                    </a:lnB>
+                    <a:noFill/>
+                  </a:tcPr>
+                </a:tc>
+              </a:tr>
+            </a:tbl>
+          </a:graphicData>
+        </a:graphic>
+      </p:graphicFrame>
     </p:spTree>
     <p:extLst>
       <p:ext uri="{BB962C8B-B14F-4D97-AF65-F5344CB8AC3E}">
@@ -8333,6 +9211,369 @@
             </a:pPr>
             <a:r>
               <a:rPr lang="ar-SA" sz="2000" b="1" dirty="0"/>
+              <a:t>المصادر والمراجع</a:t>
+            </a:r>
+            <a:endParaRPr lang="ar-SA" sz="2000" dirty="0"/>
+          </a:p>
+          <a:p>
+            <a:pPr marL="0" indent="0" algn="l" rtl="0">
+              <a:buNone/>
+            </a:pPr>
+            <a:r>
+              <a:rPr lang="en-US" sz="1600" dirty="0"/>
+              <a:t>Boylston, S. (2009). Designing sustainable packaging. Laurence King Publishing.</a:t>
+            </a:r>
+            <a:endParaRPr lang="en-US" sz="1600" dirty="0"/>
+          </a:p>
+          <a:p>
+            <a:pPr marL="0" indent="0" algn="l" rtl="0">
+              <a:buNone/>
+            </a:pPr>
+            <a:r>
+              <a:rPr lang="en-US" sz="1600" dirty="0"/>
+              <a:t>Jedlička, W. (2009). Packaging sustainability: Tools, systems and strategies for innovative package design. John Wiley &amp; Sons.</a:t>
+            </a:r>
+            <a:endParaRPr lang="en-US" sz="1600" dirty="0"/>
+          </a:p>
+          <a:p>
+            <a:pPr marL="0" indent="0" algn="l" rtl="0">
+              <a:buNone/>
+            </a:pPr>
+            <a:r>
+              <a:rPr lang="en-US" sz="1600" dirty="0"/>
+              <a:t>World Commission on Environment and Development. (1987). Our common future. Oxford University Press.</a:t>
+            </a:r>
+            <a:endParaRPr lang="en-US" sz="1600" dirty="0"/>
+          </a:p>
+          <a:p>
+            <a:pPr marL="0" indent="0" algn="l" rtl="0">
+              <a:buNone/>
+            </a:pPr>
+            <a:r>
+              <a:rPr lang="en-US" sz="1600" dirty="0"/>
+              <a:t>Elkington, J. (1997). Cannibals with forks: The triple bottom line of 21st century business. Capstone.</a:t>
+            </a:r>
+            <a:endParaRPr lang="en-US" sz="1600" dirty="0"/>
+          </a:p>
+          <a:p>
+            <a:pPr marL="0" indent="0" algn="l" rtl="0">
+              <a:buNone/>
+            </a:pPr>
+            <a:r>
+              <a:rPr lang="en-US" sz="1600" dirty="0"/>
+              <a:t>Hawkes, J. (2001). The fourth pillar of sustainability: Culture's essential role in public planning. Common Ground / Cultural Development Network.</a:t>
+            </a:r>
+            <a:endParaRPr lang="en-US" sz="1600" dirty="0"/>
+          </a:p>
+          <a:p>
+            <a:pPr marL="0" indent="0" algn="l" rtl="0">
+              <a:buNone/>
+            </a:pPr>
+            <a:r>
+              <a:rPr lang="en-US" sz="1600" dirty="0"/>
+              <a:t>United Cities and Local Governments (UCLG). (2010). Culture: Fourth pillar of sustainable development. UCLG.</a:t>
+            </a:r>
+            <a:endParaRPr lang="en-US" sz="1600" dirty="0"/>
+          </a:p>
+          <a:p>
+            <a:pPr marL="0" indent="0" algn="l" rtl="0">
+              <a:buNone/>
+            </a:pPr>
+            <a:r>
+              <a:rPr lang="en-US" sz="1600" dirty="0"/>
+              <a:t>Goodland, R. (2002). Sustainability: Human, social, economic and environmental. In Encyclopedia of global environmental change. John Wiley &amp; Sons.</a:t>
+            </a:r>
+            <a:endParaRPr lang="en-US" sz="1600" dirty="0"/>
+          </a:p>
+          <a:p>
+            <a:pPr marL="0" indent="0" algn="l" rtl="0">
+              <a:buNone/>
+            </a:pPr>
+            <a:r>
+              <a:rPr lang="en-US" sz="1600" dirty="0"/>
+              <a:t>United Nations. (2001). Indicators of sustainable development: Guidelines and methodologies (2nd ed.). UN DESA.</a:t>
+            </a:r>
+            <a:endParaRPr lang="en-US" sz="1600" dirty="0"/>
+          </a:p>
+          <a:p>
+            <a:pPr marL="0" indent="0" algn="l" rtl="0">
+              <a:buNone/>
+            </a:pPr>
+            <a:r>
+              <a:rPr lang="en-US" sz="1600" dirty="0"/>
+              <a:t>United Nations. (2015). Transforming our world: The 2030 Agenda for Sustainable Development (A/RES/70/1).</a:t>
+            </a:r>
+            <a:endParaRPr lang="en-US" sz="1600" dirty="0"/>
+          </a:p>
+        </p:txBody>
+      </p:sp>
+    </p:spTree>
+    <p:extLst>
+      <p:ext uri="{BB962C8B-B14F-4D97-AF65-F5344CB8AC3E}">
+        <p14:creationId xmlns:p14="http://schemas.microsoft.com/office/powerpoint/2010/main" val="587942976"/>
+      </p:ext>
+    </p:extLst>
+  </p:cSld>
+  <p:clrMapOvr>
+    <a:masterClrMapping/>
+  </p:clrMapOvr>
+</p:sld>
+</file>
+
+<file path=ppt/slides/slide19.xml><?xml version="1.0" encoding="utf-8"?>
+<p:sld xmlns:a="http://schemas.openxmlformats.org/drawingml/2006/main" xmlns:r="http://schemas.openxmlformats.org/officeDocument/2006/relationships" xmlns:p="http://schemas.openxmlformats.org/presentationml/2006/main">
+  <p:cSld>
+    <p:spTree>
+      <p:nvGrpSpPr>
+        <p:cNvPr id="1" name="">
+          <a:extLst>
+            <a:ext uri="{FF2B5EF4-FFF2-40B4-BE49-F238E27FC236}">
+              <a16:creationId xmlns:a16="http://schemas.microsoft.com/office/drawing/2014/main" id="{F7C2DB49-E0CB-E0AD-4519-280914AEE6EF}"/>
+            </a:ext>
+          </a:extLst>
+        </p:cNvPr>
+        <p:cNvGrpSpPr/>
+        <p:nvPr/>
+      </p:nvGrpSpPr>
+      <p:grpSpPr>
+        <a:xfrm>
+          <a:off x="0" y="0"/>
+          <a:ext cx="0" cy="0"/>
+          <a:chOff x="0" y="0"/>
+          <a:chExt cx="0" cy="0"/>
+        </a:xfrm>
+      </p:grpSpPr>
+      <p:sp>
+        <p:nvSpPr>
+          <p:cNvPr id="15" name="Footer Placeholder 3">
+            <a:extLst>
+              <a:ext uri="{FF2B5EF4-FFF2-40B4-BE49-F238E27FC236}">
+                <a16:creationId xmlns:a16="http://schemas.microsoft.com/office/drawing/2014/main" id="{865F76D3-3DE5-BC69-C45C-C71EBFDFD10E}"/>
+              </a:ext>
+            </a:extLst>
+          </p:cNvPr>
+          <p:cNvSpPr>
+            <a:spLocks noGrp="1"/>
+          </p:cNvSpPr>
+          <p:nvPr>
+            <p:ph type="ftr" sz="quarter" idx="11"/>
+          </p:nvPr>
+        </p:nvSpPr>
+        <p:spPr>
+          <a:xfrm>
+            <a:off x="4038600" y="6356350"/>
+            <a:ext cx="4114800" cy="365125"/>
+          </a:xfrm>
+        </p:spPr>
+        <p:txBody>
+          <a:bodyPr/>
+          <a:lstStyle/>
+          <a:p>
+            <a:r>
+              <a:rPr lang="ar-SA" dirty="0"/>
+              <a:t>برنامج التصميم الجرافيكي - المستوى السادس</a:t>
+            </a:r>
+            <a:endParaRPr lang="en-US" dirty="0"/>
+          </a:p>
+        </p:txBody>
+      </p:sp>
+      <p:sp>
+        <p:nvSpPr>
+          <p:cNvPr id="3" name="Content Placeholder 2">
+            <a:extLst>
+              <a:ext uri="{FF2B5EF4-FFF2-40B4-BE49-F238E27FC236}">
+                <a16:creationId xmlns:a16="http://schemas.microsoft.com/office/drawing/2014/main" id="{5EE6ED02-8F43-54FC-FB77-1E467CA54456}"/>
+              </a:ext>
+            </a:extLst>
+          </p:cNvPr>
+          <p:cNvSpPr txBox="1">
+            <a:spLocks/>
+          </p:cNvSpPr>
+          <p:nvPr/>
+        </p:nvSpPr>
+        <p:spPr>
+          <a:xfrm>
+            <a:off x="874845" y="1416963"/>
+            <a:ext cx="10442309" cy="1030380"/>
+          </a:xfrm>
+          <a:prstGeom prst="rect">
+            <a:avLst/>
+          </a:prstGeom>
+        </p:spPr>
+        <p:txBody>
+          <a:bodyPr vert="horz" lIns="91440" tIns="45720" rIns="91440" bIns="45720" rtlCol="0">
+            <a:noAutofit/>
+          </a:bodyPr>
+          <a:lstStyle>
+            <a:lvl1pPr marL="228600" indent="-228600" algn="r" defTabSz="914400" rtl="1" eaLnBrk="1" latinLnBrk="0" hangingPunct="1">
+              <a:lnSpc>
+                <a:spcPct val="90000"/>
+              </a:lnSpc>
+              <a:spcBef>
+                <a:spcPts val="1000"/>
+              </a:spcBef>
+              <a:buFont typeface="Arial" panose="020B0604020202020204" pitchFamily="34" charset="0"/>
+              <a:buChar char="•"/>
+              <a:defRPr sz="2800" kern="1200">
+                <a:solidFill>
+                  <a:schemeClr val="tx1"/>
+                </a:solidFill>
+                <a:latin typeface="Sakkal Majalla" panose="02000000000000000000" pitchFamily="2" charset="-78"/>
+                <a:ea typeface="+mn-ea"/>
+                <a:cs typeface="Sakkal Majalla" panose="02000000000000000000" pitchFamily="2" charset="-78"/>
+              </a:defRPr>
+            </a:lvl1pPr>
+            <a:lvl2pPr marL="685800" indent="-228600" algn="r" defTabSz="914400" rtl="1" eaLnBrk="1" latinLnBrk="0" hangingPunct="1">
+              <a:lnSpc>
+                <a:spcPct val="90000"/>
+              </a:lnSpc>
+              <a:spcBef>
+                <a:spcPts val="500"/>
+              </a:spcBef>
+              <a:buFont typeface="Arial" panose="020B0604020202020204" pitchFamily="34" charset="0"/>
+              <a:buChar char="•"/>
+              <a:defRPr sz="2400" kern="1200">
+                <a:solidFill>
+                  <a:schemeClr val="tx1"/>
+                </a:solidFill>
+                <a:latin typeface="Sakkal Majalla" panose="02000000000000000000" pitchFamily="2" charset="-78"/>
+                <a:ea typeface="+mn-ea"/>
+                <a:cs typeface="Sakkal Majalla" panose="02000000000000000000" pitchFamily="2" charset="-78"/>
+              </a:defRPr>
+            </a:lvl2pPr>
+            <a:lvl3pPr marL="1143000" indent="-228600" algn="r" defTabSz="914400" rtl="1" eaLnBrk="1" latinLnBrk="0" hangingPunct="1">
+              <a:lnSpc>
+                <a:spcPct val="90000"/>
+              </a:lnSpc>
+              <a:spcBef>
+                <a:spcPts val="500"/>
+              </a:spcBef>
+              <a:buFont typeface="Arial" panose="020B0604020202020204" pitchFamily="34" charset="0"/>
+              <a:buChar char="•"/>
+              <a:defRPr sz="2000" kern="1200">
+                <a:solidFill>
+                  <a:schemeClr val="tx1"/>
+                </a:solidFill>
+                <a:latin typeface="Sakkal Majalla" panose="02000000000000000000" pitchFamily="2" charset="-78"/>
+                <a:ea typeface="+mn-ea"/>
+                <a:cs typeface="Sakkal Majalla" panose="02000000000000000000" pitchFamily="2" charset="-78"/>
+              </a:defRPr>
+            </a:lvl3pPr>
+            <a:lvl4pPr marL="1600200" indent="-228600" algn="r" defTabSz="914400" rtl="1" eaLnBrk="1" latinLnBrk="0" hangingPunct="1">
+              <a:lnSpc>
+                <a:spcPct val="90000"/>
+              </a:lnSpc>
+              <a:spcBef>
+                <a:spcPts val="500"/>
+              </a:spcBef>
+              <a:buFont typeface="Arial" panose="020B0604020202020204" pitchFamily="34" charset="0"/>
+              <a:buChar char="•"/>
+              <a:defRPr sz="1800" kern="1200">
+                <a:solidFill>
+                  <a:schemeClr val="tx1"/>
+                </a:solidFill>
+                <a:latin typeface="Sakkal Majalla" panose="02000000000000000000" pitchFamily="2" charset="-78"/>
+                <a:ea typeface="+mn-ea"/>
+                <a:cs typeface="Sakkal Majalla" panose="02000000000000000000" pitchFamily="2" charset="-78"/>
+              </a:defRPr>
+            </a:lvl4pPr>
+            <a:lvl5pPr marL="2057400" indent="-228600" algn="r" defTabSz="914400" rtl="1" eaLnBrk="1" latinLnBrk="0" hangingPunct="1">
+              <a:lnSpc>
+                <a:spcPct val="90000"/>
+              </a:lnSpc>
+              <a:spcBef>
+                <a:spcPts val="500"/>
+              </a:spcBef>
+              <a:buFont typeface="Arial" panose="020B0604020202020204" pitchFamily="34" charset="0"/>
+              <a:buChar char="•"/>
+              <a:defRPr sz="1800" kern="1200">
+                <a:solidFill>
+                  <a:schemeClr val="tx1"/>
+                </a:solidFill>
+                <a:latin typeface="Sakkal Majalla" panose="02000000000000000000" pitchFamily="2" charset="-78"/>
+                <a:ea typeface="+mn-ea"/>
+                <a:cs typeface="Sakkal Majalla" panose="02000000000000000000" pitchFamily="2" charset="-78"/>
+              </a:defRPr>
+            </a:lvl5pPr>
+            <a:lvl6pPr marL="2514600" indent="-228600" algn="l" defTabSz="914400" rtl="0" eaLnBrk="1" latinLnBrk="0" hangingPunct="1">
+              <a:lnSpc>
+                <a:spcPct val="90000"/>
+              </a:lnSpc>
+              <a:spcBef>
+                <a:spcPts val="500"/>
+              </a:spcBef>
+              <a:buFont typeface="Arial" panose="020B0604020202020204" pitchFamily="34" charset="0"/>
+              <a:buChar char="•"/>
+              <a:defRPr sz="1800" kern="1200">
+                <a:solidFill>
+                  <a:schemeClr val="tx1"/>
+                </a:solidFill>
+                <a:latin typeface="+mn-lt"/>
+                <a:ea typeface="+mn-ea"/>
+                <a:cs typeface="+mn-cs"/>
+              </a:defRPr>
+            </a:lvl6pPr>
+            <a:lvl7pPr marL="2971800" indent="-228600" algn="l" defTabSz="914400" rtl="0" eaLnBrk="1" latinLnBrk="0" hangingPunct="1">
+              <a:lnSpc>
+                <a:spcPct val="90000"/>
+              </a:lnSpc>
+              <a:spcBef>
+                <a:spcPts val="500"/>
+              </a:spcBef>
+              <a:buFont typeface="Arial" panose="020B0604020202020204" pitchFamily="34" charset="0"/>
+              <a:buChar char="•"/>
+              <a:defRPr sz="1800" kern="1200">
+                <a:solidFill>
+                  <a:schemeClr val="tx1"/>
+                </a:solidFill>
+                <a:latin typeface="+mn-lt"/>
+                <a:ea typeface="+mn-ea"/>
+                <a:cs typeface="+mn-cs"/>
+              </a:defRPr>
+            </a:lvl7pPr>
+            <a:lvl8pPr marL="3429000" indent="-228600" algn="l" defTabSz="914400" rtl="0" eaLnBrk="1" latinLnBrk="0" hangingPunct="1">
+              <a:lnSpc>
+                <a:spcPct val="90000"/>
+              </a:lnSpc>
+              <a:spcBef>
+                <a:spcPts val="500"/>
+              </a:spcBef>
+              <a:buFont typeface="Arial" panose="020B0604020202020204" pitchFamily="34" charset="0"/>
+              <a:buChar char="•"/>
+              <a:defRPr sz="1800" kern="1200">
+                <a:solidFill>
+                  <a:schemeClr val="tx1"/>
+                </a:solidFill>
+                <a:latin typeface="+mn-lt"/>
+                <a:ea typeface="+mn-ea"/>
+                <a:cs typeface="+mn-cs"/>
+              </a:defRPr>
+            </a:lvl8pPr>
+            <a:lvl9pPr marL="3886200" indent="-228600" algn="l" defTabSz="914400" rtl="0" eaLnBrk="1" latinLnBrk="0" hangingPunct="1">
+              <a:lnSpc>
+                <a:spcPct val="90000"/>
+              </a:lnSpc>
+              <a:spcBef>
+                <a:spcPts val="500"/>
+              </a:spcBef>
+              <a:buFont typeface="Arial" panose="020B0604020202020204" pitchFamily="34" charset="0"/>
+              <a:buChar char="•"/>
+              <a:defRPr sz="1800" kern="1200">
+                <a:solidFill>
+                  <a:schemeClr val="tx1"/>
+                </a:solidFill>
+                <a:latin typeface="+mn-lt"/>
+                <a:ea typeface="+mn-ea"/>
+                <a:cs typeface="+mn-cs"/>
+              </a:defRPr>
+            </a:lvl9pPr>
+          </a:lstStyle>
+          <a:p>
+            <a:pPr marL="0" indent="0">
+              <a:buNone/>
+            </a:pPr>
+            <a:r>
+              <a:rPr lang="ar-SA" sz="2000" b="1" dirty="0"/>
               <a:t>المصادر والمراجع (تابع)</a:t>
             </a:r>
             <a:endParaRPr lang="ar-SA" sz="2000" dirty="0"/>
@@ -8527,9 +9768,61 @@
             </a:r>
           </a:p>
           <a:p>
-            <a:pPr marL="0" indent="0">
+            <a:pPr marL="0" indent="0" algn="just">
               <a:buNone/>
             </a:pPr>
+            <a:r>
+              <a:rPr lang="ar-SA" sz="2000" dirty="0"/>
+              <a:t xml:space="preserve">ولم تعد الاستدامة في التغليف بيئية فقط؛ بل أصبحت تشمل ستة أبعاد مترابطة: </a:t>
+            </a:r>
+            <a:r>
+              <a:rPr lang="ar-SA" sz="2000" b="1" dirty="0"/>
+              <a:t>البيئية</a:t>
+            </a:r>
+            <a:r>
+              <a:rPr lang="ar-SA" sz="2000" dirty="0"/>
+              <a:t xml:space="preserve"> و</a:t>
+            </a:r>
+            <a:r>
+              <a:rPr lang="ar-SA" sz="2000" b="1" dirty="0"/>
+              <a:t>الاقتصادية</a:t>
+            </a:r>
+            <a:r>
+              <a:rPr lang="ar-SA" sz="2000" dirty="0"/>
+              <a:t xml:space="preserve"> و</a:t>
+            </a:r>
+            <a:r>
+              <a:rPr lang="ar-SA" sz="2000" b="1" dirty="0"/>
+              <a:t>الاجتماعية</a:t>
+            </a:r>
+            <a:r>
+              <a:rPr lang="ar-SA" sz="2000" dirty="0"/>
+              <a:t xml:space="preserve"> و</a:t>
+            </a:r>
+            <a:r>
+              <a:rPr lang="ar-SA" sz="2000" b="1" dirty="0"/>
+              <a:t>الثقافية</a:t>
+            </a:r>
+            <a:r>
+              <a:rPr lang="ar-SA" sz="2000" dirty="0"/>
+              <a:t xml:space="preserve"> و</a:t>
+            </a:r>
+            <a:r>
+              <a:rPr lang="ar-SA" sz="2000" b="1" dirty="0"/>
+              <a:t>البشرية</a:t>
+            </a:r>
+            <a:r>
+              <a:rPr lang="ar-SA" sz="2000" dirty="0"/>
+              <a:t xml:space="preserve"> و</a:t>
+            </a:r>
+            <a:r>
+              <a:rPr lang="ar-SA" sz="2000" b="1" dirty="0"/>
+              <a:t>المؤسسية</a:t>
+            </a:r>
+            <a:r>
+              <a:rPr lang="ar-SA" sz="2000" dirty="0"/>
+              <a:t>. وفي هذه المحاضرة نتعرف على كل بُعد، ثم نرى كيف يطبّقه المصمم عملياً في تصميم المغلفات.</a:t>
+            </a:r>
             <a:endParaRPr lang="ar-SA" sz="2000" dirty="0"/>
           </a:p>
           <a:p>
@@ -9033,6 +10326,79 @@
           </a:extLst>
         </p:spPr>
       </p:pic>
+      <p:sp>
+        <p:nvSpPr>
+          <p:cNvPr id="906" name="Dimension Badge" descr="تطبيق لأبعاد الاستدامة: البيئي، الاقتصادي"/>
+          <p:cNvSpPr/>
+          <p:nvPr/>
+        </p:nvSpPr>
+        <p:spPr>
+          <a:xfrm>
+            <a:off x="4150000" y="520000"/>
+            <a:ext cx="5600000" cy="400000"/>
+          </a:xfrm>
+          <a:prstGeom prst="roundRect">
+            <a:avLst>
+              <a:gd name="adj" fmla="val 50000"/>
+            </a:avLst>
+          </a:prstGeom>
+          <a:solidFill>
+            <a:srgbClr val="F6F1E7"/>
+          </a:solidFill>
+          <a:ln>
+            <a:noFill/>
+          </a:ln>
+        </p:spPr>
+        <p:txBody>
+          <a:bodyPr wrap="none" lIns="182880" rIns="182880" tIns="0" bIns="0" anchor="ctr" rtlCol="1">
+            <a:noAutofit/>
+          </a:bodyPr>
+          <a:lstStyle/>
+          <a:p>
+            <a:pPr algn="r" rtl="1"/>
+            <a:r>
+              <a:rPr lang="ar-SA" sz="1600" dirty="0">
+                <a:solidFill>
+                  <a:srgbClr val="4A3B2A"/>
+                </a:solidFill>
+                <a:latin typeface="Sakkal Majalla"/>
+                <a:cs typeface="Sakkal Majalla"/>
+              </a:rPr>
+              <a:t xml:space="preserve">تطبيق لأبعاد الاستدامة: </a:t>
+            </a:r>
+            <a:r>
+              <a:rPr lang="ar-SA" sz="1600" b="1" dirty="0">
+                <a:solidFill>
+                  <a:srgbClr val="5E9C4B"/>
+                </a:solidFill>
+                <a:latin typeface="Sakkal Majalla"/>
+                <a:cs typeface="Sakkal Majalla"/>
+              </a:rPr>
+              <a:t>البيئي</a:t>
+            </a:r>
+            <a:r>
+              <a:rPr lang="ar-SA" sz="1600" dirty="0">
+                <a:solidFill>
+                  <a:srgbClr val="4A3B2A"/>
+                </a:solidFill>
+                <a:latin typeface="Sakkal Majalla"/>
+                <a:cs typeface="Sakkal Majalla"/>
+              </a:rPr>
+              <a:t xml:space="preserve"> • </a:t>
+            </a:r>
+            <a:r>
+              <a:rPr lang="ar-SA" sz="1600" b="1" dirty="0">
+                <a:solidFill>
+                  <a:srgbClr val="D9A441"/>
+                </a:solidFill>
+                <a:latin typeface="Sakkal Majalla"/>
+                <a:cs typeface="Sakkal Majalla"/>
+              </a:rPr>
+              <a:t>الاقتصادي</a:t>
+            </a:r>
+          </a:p>
+        </p:txBody>
+      </p:sp>
     </p:spTree>
     <p:extLst>
       <p:ext uri="{BB962C8B-B14F-4D97-AF65-F5344CB8AC3E}">
@@ -9437,6 +10803,99 @@
               <a:buNone/>
             </a:pPr>
             <a:endParaRPr lang="en-US" sz="2000" dirty="0"/>
+          </a:p>
+        </p:txBody>
+      </p:sp>
+      <p:sp>
+        <p:nvSpPr>
+          <p:cNvPr id="907" name="Dimension Badge" descr="تطبيق لأبعاد الاستدامة: البيئي، البشري، المؤسسي"/>
+          <p:cNvSpPr/>
+          <p:nvPr/>
+        </p:nvSpPr>
+        <p:spPr>
+          <a:xfrm>
+            <a:off x="4150000" y="520000"/>
+            <a:ext cx="5600000" cy="400000"/>
+          </a:xfrm>
+          <a:prstGeom prst="roundRect">
+            <a:avLst>
+              <a:gd name="adj" fmla="val 50000"/>
+            </a:avLst>
+          </a:prstGeom>
+          <a:solidFill>
+            <a:srgbClr val="F6F1E7"/>
+          </a:solidFill>
+          <a:ln>
+            <a:noFill/>
+          </a:ln>
+        </p:spPr>
+        <p:txBody>
+          <a:bodyPr wrap="none" lIns="182880" rIns="182880" tIns="0" bIns="0" anchor="ctr" rtlCol="1">
+            <a:noAutofit/>
+          </a:bodyPr>
+          <a:lstStyle/>
+          <a:p>
+            <a:pPr algn="r" rtl="1"/>
+            <a:r>
+              <a:rPr lang="ar-SA" sz="1600" dirty="0">
+                <a:solidFill>
+                  <a:srgbClr val="4A3B2A"/>
+                </a:solidFill>
+                <a:latin typeface="Sakkal Majalla"/>
+                <a:cs typeface="Sakkal Majalla"/>
+              </a:rPr>
+              <a:t xml:space="preserve">تطبيق لأبعاد الاستدامة: </a:t>
+            </a:r>
+            <a:r>
+              <a:rPr lang="ar-SA" sz="1600" b="1" dirty="0">
+                <a:solidFill>
+                  <a:srgbClr val="5E9C4B"/>
+                </a:solidFill>
+                <a:latin typeface="Sakkal Majalla"/>
+                <a:cs typeface="Sakkal Majalla"/>
+              </a:rPr>
+              <a:t>البيئي</a:t>
+            </a:r>
+            <a:r>
+              <a:rPr lang="ar-SA" sz="1600" dirty="0">
+                <a:solidFill>
+                  <a:srgbClr val="4A3B2A"/>
+                </a:solidFill>
+                <a:latin typeface="Sakkal Majalla"/>
+                <a:cs typeface="Sakkal Majalla"/>
+              </a:rPr>
+              <a:t xml:space="preserve"> • </a:t>
+            </a:r>
+            <a:r>
+              <a:rPr lang="ar-SA" sz="1600" b="1" dirty="0">
+                <a:solidFill>
+                  <a:srgbClr val="8A5BA8"/>
+                </a:solidFill>
+                <a:latin typeface="Sakkal Majalla"/>
+                <a:cs typeface="Sakkal Majalla"/>
+              </a:rPr>
+              <a:t>البشري</a:t>
+            </a:r>
+            <a:r>
+              <a:rPr lang="ar-SA" sz="1600" dirty="0">
+                <a:solidFill>
+                  <a:srgbClr val="4A3B2A"/>
+                </a:solidFill>
+                <a:latin typeface="Sakkal Majalla"/>
+                <a:cs typeface="Sakkal Majalla"/>
+              </a:rPr>
+              <a:t xml:space="preserve"> • </a:t>
+            </a:r>
+            <a:r>
+              <a:rPr lang="ar-SA" sz="1600" b="1" dirty="0">
+                <a:solidFill>
+                  <a:srgbClr val="3F8F8A"/>
+                </a:solidFill>
+                <a:latin typeface="Sakkal Majalla"/>
+                <a:cs typeface="Sakkal Majalla"/>
+              </a:rPr>
+              <a:t>المؤسسي</a:t>
+            </a:r>
           </a:p>
         </p:txBody>
       </p:sp>
@@ -9827,6 +11286,99 @@
           </a:p>
         </p:txBody>
       </p:sp>
+      <p:sp>
+        <p:nvSpPr>
+          <p:cNvPr id="908" name="Dimension Badge" descr="تطبيق لأبعاد الاستدامة: البيئي، البشري، المؤسسي"/>
+          <p:cNvSpPr/>
+          <p:nvPr/>
+        </p:nvSpPr>
+        <p:spPr>
+          <a:xfrm>
+            <a:off x="4150000" y="520000"/>
+            <a:ext cx="5600000" cy="400000"/>
+          </a:xfrm>
+          <a:prstGeom prst="roundRect">
+            <a:avLst>
+              <a:gd name="adj" fmla="val 50000"/>
+            </a:avLst>
+          </a:prstGeom>
+          <a:solidFill>
+            <a:srgbClr val="F6F1E7"/>
+          </a:solidFill>
+          <a:ln>
+            <a:noFill/>
+          </a:ln>
+        </p:spPr>
+        <p:txBody>
+          <a:bodyPr wrap="none" lIns="182880" rIns="182880" tIns="0" bIns="0" anchor="ctr" rtlCol="1">
+            <a:noAutofit/>
+          </a:bodyPr>
+          <a:lstStyle/>
+          <a:p>
+            <a:pPr algn="r" rtl="1"/>
+            <a:r>
+              <a:rPr lang="ar-SA" sz="1600" dirty="0">
+                <a:solidFill>
+                  <a:srgbClr val="4A3B2A"/>
+                </a:solidFill>
+                <a:latin typeface="Sakkal Majalla"/>
+                <a:cs typeface="Sakkal Majalla"/>
+              </a:rPr>
+              <a:t xml:space="preserve">تطبيق لأبعاد الاستدامة: </a:t>
+            </a:r>
+            <a:r>
+              <a:rPr lang="ar-SA" sz="1600" b="1" dirty="0">
+                <a:solidFill>
+                  <a:srgbClr val="5E9C4B"/>
+                </a:solidFill>
+                <a:latin typeface="Sakkal Majalla"/>
+                <a:cs typeface="Sakkal Majalla"/>
+              </a:rPr>
+              <a:t>البيئي</a:t>
+            </a:r>
+            <a:r>
+              <a:rPr lang="ar-SA" sz="1600" dirty="0">
+                <a:solidFill>
+                  <a:srgbClr val="4A3B2A"/>
+                </a:solidFill>
+                <a:latin typeface="Sakkal Majalla"/>
+                <a:cs typeface="Sakkal Majalla"/>
+              </a:rPr>
+              <a:t xml:space="preserve"> • </a:t>
+            </a:r>
+            <a:r>
+              <a:rPr lang="ar-SA" sz="1600" b="1" dirty="0">
+                <a:solidFill>
+                  <a:srgbClr val="8A5BA8"/>
+                </a:solidFill>
+                <a:latin typeface="Sakkal Majalla"/>
+                <a:cs typeface="Sakkal Majalla"/>
+              </a:rPr>
+              <a:t>البشري</a:t>
+            </a:r>
+            <a:r>
+              <a:rPr lang="ar-SA" sz="1600" dirty="0">
+                <a:solidFill>
+                  <a:srgbClr val="4A3B2A"/>
+                </a:solidFill>
+                <a:latin typeface="Sakkal Majalla"/>
+                <a:cs typeface="Sakkal Majalla"/>
+              </a:rPr>
+              <a:t xml:space="preserve"> • </a:t>
+            </a:r>
+            <a:r>
+              <a:rPr lang="ar-SA" sz="1600" b="1" dirty="0">
+                <a:solidFill>
+                  <a:srgbClr val="3F8F8A"/>
+                </a:solidFill>
+                <a:latin typeface="Sakkal Majalla"/>
+                <a:cs typeface="Sakkal Majalla"/>
+              </a:rPr>
+              <a:t>المؤسسي</a:t>
+            </a:r>
+          </a:p>
+        </p:txBody>
+      </p:sp>
     </p:spTree>
     <p:extLst>
       <p:ext uri="{BB962C8B-B14F-4D97-AF65-F5344CB8AC3E}">
@@ -10219,6 +11771,99 @@
               <a:buNone/>
             </a:pPr>
             <a:endParaRPr lang="en-US" sz="2000" dirty="0"/>
+          </a:p>
+        </p:txBody>
+      </p:sp>
+      <p:sp>
+        <p:nvSpPr>
+          <p:cNvPr id="909" name="Dimension Badge" descr="تطبيق لأبعاد الاستدامة: البيئي، البشري، المؤسسي"/>
+          <p:cNvSpPr/>
+          <p:nvPr/>
+        </p:nvSpPr>
+        <p:spPr>
+          <a:xfrm>
+            <a:off x="4150000" y="520000"/>
+            <a:ext cx="5600000" cy="400000"/>
+          </a:xfrm>
+          <a:prstGeom prst="roundRect">
+            <a:avLst>
+              <a:gd name="adj" fmla="val 50000"/>
+            </a:avLst>
+          </a:prstGeom>
+          <a:solidFill>
+            <a:srgbClr val="F6F1E7"/>
+          </a:solidFill>
+          <a:ln>
+            <a:noFill/>
+          </a:ln>
+        </p:spPr>
+        <p:txBody>
+          <a:bodyPr wrap="none" lIns="182880" rIns="182880" tIns="0" bIns="0" anchor="ctr" rtlCol="1">
+            <a:noAutofit/>
+          </a:bodyPr>
+          <a:lstStyle/>
+          <a:p>
+            <a:pPr algn="r" rtl="1"/>
+            <a:r>
+              <a:rPr lang="ar-SA" sz="1600" dirty="0">
+                <a:solidFill>
+                  <a:srgbClr val="4A3B2A"/>
+                </a:solidFill>
+                <a:latin typeface="Sakkal Majalla"/>
+                <a:cs typeface="Sakkal Majalla"/>
+              </a:rPr>
+              <a:t xml:space="preserve">تطبيق لأبعاد الاستدامة: </a:t>
+            </a:r>
+            <a:r>
+              <a:rPr lang="ar-SA" sz="1600" b="1" dirty="0">
+                <a:solidFill>
+                  <a:srgbClr val="5E9C4B"/>
+                </a:solidFill>
+                <a:latin typeface="Sakkal Majalla"/>
+                <a:cs typeface="Sakkal Majalla"/>
+              </a:rPr>
+              <a:t>البيئي</a:t>
+            </a:r>
+            <a:r>
+              <a:rPr lang="ar-SA" sz="1600" dirty="0">
+                <a:solidFill>
+                  <a:srgbClr val="4A3B2A"/>
+                </a:solidFill>
+                <a:latin typeface="Sakkal Majalla"/>
+                <a:cs typeface="Sakkal Majalla"/>
+              </a:rPr>
+              <a:t xml:space="preserve"> • </a:t>
+            </a:r>
+            <a:r>
+              <a:rPr lang="ar-SA" sz="1600" b="1" dirty="0">
+                <a:solidFill>
+                  <a:srgbClr val="8A5BA8"/>
+                </a:solidFill>
+                <a:latin typeface="Sakkal Majalla"/>
+                <a:cs typeface="Sakkal Majalla"/>
+              </a:rPr>
+              <a:t>البشري</a:t>
+            </a:r>
+            <a:r>
+              <a:rPr lang="ar-SA" sz="1600" dirty="0">
+                <a:solidFill>
+                  <a:srgbClr val="4A3B2A"/>
+                </a:solidFill>
+                <a:latin typeface="Sakkal Majalla"/>
+                <a:cs typeface="Sakkal Majalla"/>
+              </a:rPr>
+              <a:t xml:space="preserve"> • </a:t>
+            </a:r>
+            <a:r>
+              <a:rPr lang="ar-SA" sz="1600" b="1" dirty="0">
+                <a:solidFill>
+                  <a:srgbClr val="3F8F8A"/>
+                </a:solidFill>
+                <a:latin typeface="Sakkal Majalla"/>
+                <a:cs typeface="Sakkal Majalla"/>
+              </a:rPr>
+              <a:t>المؤسسي</a:t>
+            </a:r>
           </a:p>
         </p:txBody>
       </p:sp>
@@ -10649,6 +12294,79 @@
           </a:prstGeom>
         </p:spPr>
       </p:pic>
+      <p:sp>
+        <p:nvSpPr>
+          <p:cNvPr id="910" name="Dimension Badge" descr="تطبيق لأبعاد الاستدامة: البيئي، المؤسسي"/>
+          <p:cNvSpPr/>
+          <p:nvPr/>
+        </p:nvSpPr>
+        <p:spPr>
+          <a:xfrm>
+            <a:off x="4150000" y="520000"/>
+            <a:ext cx="5600000" cy="400000"/>
+          </a:xfrm>
+          <a:prstGeom prst="roundRect">
+            <a:avLst>
+              <a:gd name="adj" fmla="val 50000"/>
+            </a:avLst>
+          </a:prstGeom>
+          <a:solidFill>
+            <a:srgbClr val="F6F1E7"/>
+          </a:solidFill>
+          <a:ln>
+            <a:noFill/>
+          </a:ln>
+        </p:spPr>
+        <p:txBody>
+          <a:bodyPr wrap="none" lIns="182880" rIns="182880" tIns="0" bIns="0" anchor="ctr" rtlCol="1">
+            <a:noAutofit/>
+          </a:bodyPr>
+          <a:lstStyle/>
+          <a:p>
+            <a:pPr algn="r" rtl="1"/>
+            <a:r>
+              <a:rPr lang="ar-SA" sz="1600" dirty="0">
+                <a:solidFill>
+                  <a:srgbClr val="4A3B2A"/>
+                </a:solidFill>
+                <a:latin typeface="Sakkal Majalla"/>
+                <a:cs typeface="Sakkal Majalla"/>
+              </a:rPr>
+              <a:t xml:space="preserve">تطبيق لأبعاد الاستدامة: </a:t>
+            </a:r>
+            <a:r>
+              <a:rPr lang="ar-SA" sz="1600" b="1" dirty="0">
+                <a:solidFill>
+                  <a:srgbClr val="5E9C4B"/>
+                </a:solidFill>
+                <a:latin typeface="Sakkal Majalla"/>
+                <a:cs typeface="Sakkal Majalla"/>
+              </a:rPr>
+              <a:t>البيئي</a:t>
+            </a:r>
+            <a:r>
+              <a:rPr lang="ar-SA" sz="1600" dirty="0">
+                <a:solidFill>
+                  <a:srgbClr val="4A3B2A"/>
+                </a:solidFill>
+                <a:latin typeface="Sakkal Majalla"/>
+                <a:cs typeface="Sakkal Majalla"/>
+              </a:rPr>
+              <a:t xml:space="preserve"> • </a:t>
+            </a:r>
+            <a:r>
+              <a:rPr lang="ar-SA" sz="1600" b="1" dirty="0">
+                <a:solidFill>
+                  <a:srgbClr val="3F8F8A"/>
+                </a:solidFill>
+                <a:latin typeface="Sakkal Majalla"/>
+                <a:cs typeface="Sakkal Majalla"/>
+              </a:rPr>
+              <a:t>المؤسسي</a:t>
+            </a:r>
+          </a:p>
+        </p:txBody>
+      </p:sp>
     </p:spTree>
     <p:extLst>
       <p:ext uri="{BB962C8B-B14F-4D97-AF65-F5344CB8AC3E}">
@@ -11122,6 +12840,79 @@
           </a:extLst>
         </p:spPr>
       </p:pic>
+      <p:sp>
+        <p:nvSpPr>
+          <p:cNvPr id="911" name="Dimension Badge" descr="تطبيق لأبعاد الاستدامة: البيئي، الاجتماعي"/>
+          <p:cNvSpPr/>
+          <p:nvPr/>
+        </p:nvSpPr>
+        <p:spPr>
+          <a:xfrm>
+            <a:off x="4150000" y="520000"/>
+            <a:ext cx="5600000" cy="400000"/>
+          </a:xfrm>
+          <a:prstGeom prst="roundRect">
+            <a:avLst>
+              <a:gd name="adj" fmla="val 50000"/>
+            </a:avLst>
+          </a:prstGeom>
+          <a:solidFill>
+            <a:srgbClr val="F6F1E7"/>
+          </a:solidFill>
+          <a:ln>
+            <a:noFill/>
+          </a:ln>
+        </p:spPr>
+        <p:txBody>
+          <a:bodyPr wrap="none" lIns="182880" rIns="182880" tIns="0" bIns="0" anchor="ctr" rtlCol="1">
+            <a:noAutofit/>
+          </a:bodyPr>
+          <a:lstStyle/>
+          <a:p>
+            <a:pPr algn="r" rtl="1"/>
+            <a:r>
+              <a:rPr lang="ar-SA" sz="1600" dirty="0">
+                <a:solidFill>
+                  <a:srgbClr val="4A3B2A"/>
+                </a:solidFill>
+                <a:latin typeface="Sakkal Majalla"/>
+                <a:cs typeface="Sakkal Majalla"/>
+              </a:rPr>
+              <a:t xml:space="preserve">تطبيق لأبعاد الاستدامة: </a:t>
+            </a:r>
+            <a:r>
+              <a:rPr lang="ar-SA" sz="1600" b="1" dirty="0">
+                <a:solidFill>
+                  <a:srgbClr val="5E9C4B"/>
+                </a:solidFill>
+                <a:latin typeface="Sakkal Majalla"/>
+                <a:cs typeface="Sakkal Majalla"/>
+              </a:rPr>
+              <a:t>البيئي</a:t>
+            </a:r>
+            <a:r>
+              <a:rPr lang="ar-SA" sz="1600" dirty="0">
+                <a:solidFill>
+                  <a:srgbClr val="4A3B2A"/>
+                </a:solidFill>
+                <a:latin typeface="Sakkal Majalla"/>
+                <a:cs typeface="Sakkal Majalla"/>
+              </a:rPr>
+              <a:t xml:space="preserve"> • </a:t>
+            </a:r>
+            <a:r>
+              <a:rPr lang="ar-SA" sz="1600" b="1" dirty="0">
+                <a:solidFill>
+                  <a:srgbClr val="4B7FA8"/>
+                </a:solidFill>
+                <a:latin typeface="Sakkal Majalla"/>
+                <a:cs typeface="Sakkal Majalla"/>
+              </a:rPr>
+              <a:t>الاجتماعي</a:t>
+            </a:r>
+          </a:p>
+        </p:txBody>
+      </p:sp>
     </p:spTree>
     <p:extLst>
       <p:ext uri="{BB962C8B-B14F-4D97-AF65-F5344CB8AC3E}">
@@ -11524,6 +13315,99 @@
           </a:prstGeom>
         </p:spPr>
       </p:pic>
+      <p:sp>
+        <p:nvSpPr>
+          <p:cNvPr id="912" name="Dimension Badge" descr="تطبيق لأبعاد الاستدامة: الاقتصادي، الاجتماعي، الثقافي"/>
+          <p:cNvSpPr/>
+          <p:nvPr/>
+        </p:nvSpPr>
+        <p:spPr>
+          <a:xfrm>
+            <a:off x="4150000" y="520000"/>
+            <a:ext cx="5600000" cy="400000"/>
+          </a:xfrm>
+          <a:prstGeom prst="roundRect">
+            <a:avLst>
+              <a:gd name="adj" fmla="val 50000"/>
+            </a:avLst>
+          </a:prstGeom>
+          <a:solidFill>
+            <a:srgbClr val="F6F1E7"/>
+          </a:solidFill>
+          <a:ln>
+            <a:noFill/>
+          </a:ln>
+        </p:spPr>
+        <p:txBody>
+          <a:bodyPr wrap="none" lIns="182880" rIns="182880" tIns="0" bIns="0" anchor="ctr" rtlCol="1">
+            <a:noAutofit/>
+          </a:bodyPr>
+          <a:lstStyle/>
+          <a:p>
+            <a:pPr algn="r" rtl="1"/>
+            <a:r>
+              <a:rPr lang="ar-SA" sz="1600" dirty="0">
+                <a:solidFill>
+                  <a:srgbClr val="4A3B2A"/>
+                </a:solidFill>
+                <a:latin typeface="Sakkal Majalla"/>
+                <a:cs typeface="Sakkal Majalla"/>
+              </a:rPr>
+              <a:t xml:space="preserve">تطبيق لأبعاد الاستدامة: </a:t>
+            </a:r>
+            <a:r>
+              <a:rPr lang="ar-SA" sz="1600" b="1" dirty="0">
+                <a:solidFill>
+                  <a:srgbClr val="D9A441"/>
+                </a:solidFill>
+                <a:latin typeface="Sakkal Majalla"/>
+                <a:cs typeface="Sakkal Majalla"/>
+              </a:rPr>
+              <a:t>الاقتصادي</a:t>
+            </a:r>
+            <a:r>
+              <a:rPr lang="ar-SA" sz="1600" dirty="0">
+                <a:solidFill>
+                  <a:srgbClr val="4A3B2A"/>
+                </a:solidFill>
+                <a:latin typeface="Sakkal Majalla"/>
+                <a:cs typeface="Sakkal Majalla"/>
+              </a:rPr>
+              <a:t xml:space="preserve"> • </a:t>
+            </a:r>
+            <a:r>
+              <a:rPr lang="ar-SA" sz="1600" b="1" dirty="0">
+                <a:solidFill>
+                  <a:srgbClr val="4B7FA8"/>
+                </a:solidFill>
+                <a:latin typeface="Sakkal Majalla"/>
+                <a:cs typeface="Sakkal Majalla"/>
+              </a:rPr>
+              <a:t>الاجتماعي</a:t>
+            </a:r>
+            <a:r>
+              <a:rPr lang="ar-SA" sz="1600" dirty="0">
+                <a:solidFill>
+                  <a:srgbClr val="4A3B2A"/>
+                </a:solidFill>
+                <a:latin typeface="Sakkal Majalla"/>
+                <a:cs typeface="Sakkal Majalla"/>
+              </a:rPr>
+              <a:t xml:space="preserve"> • </a:t>
+            </a:r>
+            <a:r>
+              <a:rPr lang="ar-SA" sz="1600" b="1" dirty="0">
+                <a:solidFill>
+                  <a:srgbClr val="B5473A"/>
+                </a:solidFill>
+                <a:latin typeface="Sakkal Majalla"/>
+                <a:cs typeface="Sakkal Majalla"/>
+              </a:rPr>
+              <a:t>الثقافي</a:t>
+            </a:r>
+          </a:p>
+        </p:txBody>
+      </p:sp>
     </p:spTree>
     <p:extLst>
       <p:ext uri="{BB962C8B-B14F-4D97-AF65-F5344CB8AC3E}">

</xml_diff>